<commit_message>
Updated Consortium Organizational Plan
</commit_message>
<xml_diff>
--- a/docs/1_Integration/1a_Governance/AccelRR8 Consortium Non-Profit Organization Plan.pptx
+++ b/docs/1_Integration/1a_Governance/AccelRR8 Consortium Non-Profit Organization Plan.pptx
@@ -271,8 +271,8 @@
 <pc:chgInfo xmlns:a="http://schemas.openxmlformats.org/drawingml/2006/main" xmlns:r="http://schemas.openxmlformats.org/officeDocument/2006/relationships" xmlns:ac="http://schemas.microsoft.com/office/drawing/2013/main/command" xmlns:pc="http://schemas.microsoft.com/office/powerpoint/2013/main/command">
   <pc:docChgLst>
     <pc:chgData name="Rich Reba" userId="55db41ab6eb3f845" providerId="LiveId" clId="{0E19DA16-244C-5B50-BE0F-52911DD4CA7E}"/>
-    <pc:docChg chg="modSld">
-      <pc:chgData name="Rich Reba" userId="55db41ab6eb3f845" providerId="LiveId" clId="{0E19DA16-244C-5B50-BE0F-52911DD4CA7E}" dt="2026-08-06T16:33:58.650" v="466" actId="20577"/>
+    <pc:docChg chg="undo custSel modSld">
+      <pc:chgData name="Rich Reba" userId="55db41ab6eb3f845" providerId="LiveId" clId="{0E19DA16-244C-5B50-BE0F-52911DD4CA7E}" dt="2026-08-06T16:41:43.287" v="519" actId="20577"/>
       <pc:docMkLst>
         <pc:docMk/>
       </pc:docMkLst>
@@ -292,7 +292,7 @@
         </pc:spChg>
       </pc:sldChg>
       <pc:sldChg chg="modSp mod">
-        <pc:chgData name="Rich Reba" userId="55db41ab6eb3f845" providerId="LiveId" clId="{0E19DA16-244C-5B50-BE0F-52911DD4CA7E}" dt="2026-08-06T16:21:42.694" v="12" actId="20577"/>
+        <pc:chgData name="Rich Reba" userId="55db41ab6eb3f845" providerId="LiveId" clId="{0E19DA16-244C-5B50-BE0F-52911DD4CA7E}" dt="2026-08-06T16:40:50.057" v="505" actId="20577"/>
         <pc:sldMkLst>
           <pc:docMk/>
           <pc:sldMk cId="1656586467" sldId="274"/>
@@ -319,6 +319,53 @@
             <pc:docMk/>
             <pc:sldMk cId="1656586467" sldId="274"/>
             <ac:spMk id="127" creationId="{00000000-0000-0000-0000-000000000000}"/>
+          </ac:spMkLst>
+        </pc:spChg>
+        <pc:spChg chg="mod">
+          <ac:chgData name="Rich Reba" userId="55db41ab6eb3f845" providerId="LiveId" clId="{0E19DA16-244C-5B50-BE0F-52911DD4CA7E}" dt="2026-08-06T16:40:44.419" v="501" actId="20577"/>
+          <ac:spMkLst>
+            <pc:docMk/>
+            <pc:sldMk cId="1656586467" sldId="274"/>
+            <ac:spMk id="128" creationId="{00000000-0000-0000-0000-000000000000}"/>
+          </ac:spMkLst>
+        </pc:spChg>
+        <pc:spChg chg="mod">
+          <ac:chgData name="Rich Reba" userId="55db41ab6eb3f845" providerId="LiveId" clId="{0E19DA16-244C-5B50-BE0F-52911DD4CA7E}" dt="2026-08-06T16:40:47.360" v="503" actId="20577"/>
+          <ac:spMkLst>
+            <pc:docMk/>
+            <pc:sldMk cId="1656586467" sldId="274"/>
+            <ac:spMk id="129" creationId="{00000000-0000-0000-0000-000000000000}"/>
+          </ac:spMkLst>
+        </pc:spChg>
+        <pc:spChg chg="mod">
+          <ac:chgData name="Rich Reba" userId="55db41ab6eb3f845" providerId="LiveId" clId="{0E19DA16-244C-5B50-BE0F-52911DD4CA7E}" dt="2026-08-06T16:40:50.057" v="505" actId="20577"/>
+          <ac:spMkLst>
+            <pc:docMk/>
+            <pc:sldMk cId="1656586467" sldId="274"/>
+            <ac:spMk id="130" creationId="{00000000-0000-0000-0000-000000000000}"/>
+          </ac:spMkLst>
+        </pc:spChg>
+      </pc:sldChg>
+      <pc:sldChg chg="modSp mod">
+        <pc:chgData name="Rich Reba" userId="55db41ab6eb3f845" providerId="LiveId" clId="{0E19DA16-244C-5B50-BE0F-52911DD4CA7E}" dt="2026-08-06T16:41:43.287" v="519" actId="20577"/>
+        <pc:sldMkLst>
+          <pc:docMk/>
+          <pc:sldMk cId="3472351846" sldId="280"/>
+        </pc:sldMkLst>
+        <pc:spChg chg="mod">
+          <ac:chgData name="Rich Reba" userId="55db41ab6eb3f845" providerId="LiveId" clId="{0E19DA16-244C-5B50-BE0F-52911DD4CA7E}" dt="2026-08-06T16:41:04.023" v="517" actId="20577"/>
+          <ac:spMkLst>
+            <pc:docMk/>
+            <pc:sldMk cId="3472351846" sldId="280"/>
+            <ac:spMk id="4" creationId="{BDC3AF1A-7A80-3B3D-294A-E26C982690C3}"/>
+          </ac:spMkLst>
+        </pc:spChg>
+        <pc:spChg chg="mod">
+          <ac:chgData name="Rich Reba" userId="55db41ab6eb3f845" providerId="LiveId" clId="{0E19DA16-244C-5B50-BE0F-52911DD4CA7E}" dt="2026-08-06T16:41:43.287" v="519" actId="20577"/>
+          <ac:spMkLst>
+            <pc:docMk/>
+            <pc:sldMk cId="3472351846" sldId="280"/>
+            <ac:spMk id="5" creationId="{27DCB550-ECF5-EE2D-D835-8F66E64FAB2B}"/>
           </ac:spMkLst>
         </pc:spChg>
       </pc:sldChg>
@@ -12701,7 +12748,7 @@
           <a:p>
             <a:r>
               <a:rPr lang="en-US" sz="1800" dirty="0"/>
-              <a:t>AccelRR8 LLC, a for-profit company, is not an affiliate.  It is a patron whose employees and associates are collaborators in the consortium</a:t>
+              <a:t>AccelRR8 LLC, a for-profit company, is not an affiliate.  It is a patron whose employees and associates are participants in the consortium</a:t>
             </a:r>
           </a:p>
           <a:p>
@@ -13531,7 +13578,7 @@
                 <a:cs typeface="Calibri"/>
                 <a:sym typeface="Calibri"/>
               </a:rPr>
-              <a:t>1,000 Collaborators</a:t>
+              <a:t>1,000 Subscribers</a:t>
             </a:r>
           </a:p>
           <a:p>
@@ -13724,7 +13771,7 @@
                 <a:cs typeface="Calibri"/>
                 <a:sym typeface="Calibri"/>
               </a:rPr>
-              <a:t>3 Patron Organizations</a:t>
+              <a:t>3 Patrons</a:t>
             </a:r>
           </a:p>
         </p:txBody>
@@ -13795,7 +13842,7 @@
                 <a:cs typeface="Calibri"/>
                 <a:sym typeface="Calibri"/>
               </a:rPr>
-              <a:t>3,000 Collaborators</a:t>
+              <a:t>3,000 Subscribers</a:t>
             </a:r>
           </a:p>
           <a:p>
@@ -13966,7 +14013,7 @@
                 <a:cs typeface="Calibri"/>
                 <a:sym typeface="Calibri"/>
               </a:rPr>
-              <a:t>10 Patron Organizations</a:t>
+              <a:t>10 Patrons</a:t>
             </a:r>
           </a:p>
           <a:p>
@@ -14080,7 +14127,7 @@
                 <a:cs typeface="Calibri"/>
                 <a:sym typeface="Calibri"/>
               </a:rPr>
-              <a:t>10,000 Collaborators</a:t>
+              <a:t>10,000 Subscribers</a:t>
             </a:r>
           </a:p>
           <a:p>
@@ -14252,7 +14299,7 @@
                 <a:cs typeface="Calibri"/>
                 <a:sym typeface="Calibri"/>
               </a:rPr>
-              <a:t>30 Patron Organizations</a:t>
+              <a:t>30 Patrons</a:t>
             </a:r>
           </a:p>
           <a:p>

</xml_diff>

<commit_message>
Updated Consortium Business Plan images
</commit_message>
<xml_diff>
--- a/docs/1_Integration/1a_Governance/AccelRR8 Consortium Non-Profit Organization Plan.pptx
+++ b/docs/1_Integration/1a_Governance/AccelRR8 Consortium Non-Profit Organization Plan.pptx
@@ -253,7 +253,7 @@
       <p15:sldGuideLst xmlns:p15="http://schemas.microsoft.com/office/powerpoint/2012/main"/>
     </p:ext>
     <p:ext uri="GoogleSlidesCustomDataVersion2">
-      <go:slidesCustomData xmlns="" xmlns:mc="http://schemas.openxmlformats.org/markup-compatibility/2006" xmlns:mv="urn:schemas-microsoft-com:mac:vml" xmlns:c="http://schemas.openxmlformats.org/drawingml/2006/chart" xmlns:dgm="http://schemas.openxmlformats.org/drawingml/2006/diagram" xmlns:o="urn:schemas-microsoft-com:office:office" xmlns:v="urn:schemas-microsoft-com:vml" xmlns:pvml="urn:schemas-microsoft-com:office:powerpoint" xmlns:com="http://schemas.openxmlformats.org/drawingml/2006/compatibility" xmlns:p14="http://schemas.microsoft.com/office/powerpoint/2010/main" xmlns:p15="http://schemas.microsoft.com/office/powerpoint/2012/main" xmlns:ahyp="http://schemas.microsoft.com/office/drawing/2018/hyperlinkcolor" xmlns:go="http://customooxmlschemas.google.com/" r:id="rId13" roundtripDataSignature="AMtx7mhwEp+Eio5qReXqYqUwMP31HB0A8A=="/>
+      <go:slidesCustomData xmlns:go="http://customooxmlschemas.google.com/" xmlns:ahyp="http://schemas.microsoft.com/office/drawing/2018/hyperlinkcolor" xmlns:p15="http://schemas.microsoft.com/office/powerpoint/2012/main" xmlns:p14="http://schemas.microsoft.com/office/powerpoint/2010/main" xmlns:com="http://schemas.openxmlformats.org/drawingml/2006/compatibility" xmlns:pvml="urn:schemas-microsoft-com:office:powerpoint" xmlns:v="urn:schemas-microsoft-com:vml" xmlns:o="urn:schemas-microsoft-com:office:office" xmlns:dgm="http://schemas.openxmlformats.org/drawingml/2006/diagram" xmlns:c="http://schemas.openxmlformats.org/drawingml/2006/chart" xmlns:mv="urn:schemas-microsoft-com:mac:vml" xmlns:mc="http://schemas.openxmlformats.org/markup-compatibility/2006" xmlns="" r:id="rId13" roundtripDataSignature="AMtx7mhwEp+Eio5qReXqYqUwMP31HB0A8A=="/>
     </p:ext>
   </p:extLst>
 </p:presentation>
@@ -272,16 +272,24 @@
   <pc:docChgLst>
     <pc:chgData name="Rich Reba" userId="55db41ab6eb3f845" providerId="LiveId" clId="{0E19DA16-244C-5B50-BE0F-52911DD4CA7E}"/>
     <pc:docChg chg="undo custSel modSld">
-      <pc:chgData name="Rich Reba" userId="55db41ab6eb3f845" providerId="LiveId" clId="{0E19DA16-244C-5B50-BE0F-52911DD4CA7E}" dt="2026-08-06T16:41:43.287" v="519" actId="20577"/>
+      <pc:chgData name="Rich Reba" userId="55db41ab6eb3f845" providerId="LiveId" clId="{0E19DA16-244C-5B50-BE0F-52911DD4CA7E}" dt="2026-08-10T12:07:20.066" v="527" actId="478"/>
       <pc:docMkLst>
         <pc:docMk/>
       </pc:docMkLst>
-      <pc:sldChg chg="modSp mod">
-        <pc:chgData name="Rich Reba" userId="55db41ab6eb3f845" providerId="LiveId" clId="{0E19DA16-244C-5B50-BE0F-52911DD4CA7E}" dt="2026-08-06T16:20:55.520" v="9" actId="20577"/>
+      <pc:sldChg chg="delSp modSp mod">
+        <pc:chgData name="Rich Reba" userId="55db41ab6eb3f845" providerId="LiveId" clId="{0E19DA16-244C-5B50-BE0F-52911DD4CA7E}" dt="2026-08-10T12:06:55.065" v="522" actId="478"/>
         <pc:sldMkLst>
           <pc:docMk/>
           <pc:sldMk cId="0" sldId="256"/>
         </pc:sldMkLst>
+        <pc:spChg chg="del">
+          <ac:chgData name="Rich Reba" userId="55db41ab6eb3f845" providerId="LiveId" clId="{0E19DA16-244C-5B50-BE0F-52911DD4CA7E}" dt="2026-08-10T12:06:55.065" v="522" actId="478"/>
+          <ac:spMkLst>
+            <pc:docMk/>
+            <pc:sldMk cId="0" sldId="256"/>
+            <ac:spMk id="2" creationId="{00C41C28-1F72-7447-74D3-F57B36646C52}"/>
+          </ac:spMkLst>
+        </pc:spChg>
         <pc:spChg chg="mod">
           <ac:chgData name="Rich Reba" userId="55db41ab6eb3f845" providerId="LiveId" clId="{0E19DA16-244C-5B50-BE0F-52911DD4CA7E}" dt="2026-08-06T16:20:55.520" v="9" actId="20577"/>
           <ac:spMkLst>
@@ -291,12 +299,35 @@
           </ac:spMkLst>
         </pc:spChg>
       </pc:sldChg>
-      <pc:sldChg chg="modSp mod">
-        <pc:chgData name="Rich Reba" userId="55db41ab6eb3f845" providerId="LiveId" clId="{0E19DA16-244C-5B50-BE0F-52911DD4CA7E}" dt="2026-08-06T16:40:50.057" v="505" actId="20577"/>
+      <pc:sldChg chg="delSp mod">
+        <pc:chgData name="Rich Reba" userId="55db41ab6eb3f845" providerId="LiveId" clId="{0E19DA16-244C-5B50-BE0F-52911DD4CA7E}" dt="2026-08-10T12:06:52.373" v="521" actId="478"/>
+        <pc:sldMkLst>
+          <pc:docMk/>
+          <pc:sldMk cId="0" sldId="257"/>
+        </pc:sldMkLst>
+        <pc:spChg chg="del">
+          <ac:chgData name="Rich Reba" userId="55db41ab6eb3f845" providerId="LiveId" clId="{0E19DA16-244C-5B50-BE0F-52911DD4CA7E}" dt="2026-08-10T12:06:52.373" v="521" actId="478"/>
+          <ac:spMkLst>
+            <pc:docMk/>
+            <pc:sldMk cId="0" sldId="257"/>
+            <ac:spMk id="2" creationId="{2F16A1F0-E195-BF45-032B-42BF906BEC9A}"/>
+          </ac:spMkLst>
+        </pc:spChg>
+      </pc:sldChg>
+      <pc:sldChg chg="delSp modSp mod">
+        <pc:chgData name="Rich Reba" userId="55db41ab6eb3f845" providerId="LiveId" clId="{0E19DA16-244C-5B50-BE0F-52911DD4CA7E}" dt="2026-08-10T12:06:59.856" v="523" actId="478"/>
         <pc:sldMkLst>
           <pc:docMk/>
           <pc:sldMk cId="1656586467" sldId="274"/>
         </pc:sldMkLst>
+        <pc:spChg chg="del">
+          <ac:chgData name="Rich Reba" userId="55db41ab6eb3f845" providerId="LiveId" clId="{0E19DA16-244C-5B50-BE0F-52911DD4CA7E}" dt="2026-08-10T12:06:59.856" v="523" actId="478"/>
+          <ac:spMkLst>
+            <pc:docMk/>
+            <pc:sldMk cId="1656586467" sldId="274"/>
+            <ac:spMk id="6" creationId="{CF348359-6A33-94C2-7023-E826A712A5B3}"/>
+          </ac:spMkLst>
+        </pc:spChg>
         <pc:spChg chg="mod">
           <ac:chgData name="Rich Reba" userId="55db41ab6eb3f845" providerId="LiveId" clId="{0E19DA16-244C-5B50-BE0F-52911DD4CA7E}" dt="2026-08-06T16:21:32.989" v="10" actId="20577"/>
           <ac:spMkLst>
@@ -346,12 +377,20 @@
           </ac:spMkLst>
         </pc:spChg>
       </pc:sldChg>
-      <pc:sldChg chg="modSp mod">
-        <pc:chgData name="Rich Reba" userId="55db41ab6eb3f845" providerId="LiveId" clId="{0E19DA16-244C-5B50-BE0F-52911DD4CA7E}" dt="2026-08-06T16:41:43.287" v="519" actId="20577"/>
+      <pc:sldChg chg="delSp modSp mod">
+        <pc:chgData name="Rich Reba" userId="55db41ab6eb3f845" providerId="LiveId" clId="{0E19DA16-244C-5B50-BE0F-52911DD4CA7E}" dt="2026-08-10T12:06:48.887" v="520" actId="478"/>
         <pc:sldMkLst>
           <pc:docMk/>
           <pc:sldMk cId="3472351846" sldId="280"/>
         </pc:sldMkLst>
+        <pc:spChg chg="del">
+          <ac:chgData name="Rich Reba" userId="55db41ab6eb3f845" providerId="LiveId" clId="{0E19DA16-244C-5B50-BE0F-52911DD4CA7E}" dt="2026-08-10T12:06:48.887" v="520" actId="478"/>
+          <ac:spMkLst>
+            <pc:docMk/>
+            <pc:sldMk cId="3472351846" sldId="280"/>
+            <ac:spMk id="2" creationId="{4B602561-35D8-AF27-76E9-EB18F18FC081}"/>
+          </ac:spMkLst>
+        </pc:spChg>
         <pc:spChg chg="mod">
           <ac:chgData name="Rich Reba" userId="55db41ab6eb3f845" providerId="LiveId" clId="{0E19DA16-244C-5B50-BE0F-52911DD4CA7E}" dt="2026-08-06T16:41:04.023" v="517" actId="20577"/>
           <ac:spMkLst>
@@ -369,12 +408,20 @@
           </ac:spMkLst>
         </pc:spChg>
       </pc:sldChg>
-      <pc:sldChg chg="modSp mod">
-        <pc:chgData name="Rich Reba" userId="55db41ab6eb3f845" providerId="LiveId" clId="{0E19DA16-244C-5B50-BE0F-52911DD4CA7E}" dt="2026-08-06T16:28:21.663" v="199" actId="20577"/>
+      <pc:sldChg chg="delSp modSp mod">
+        <pc:chgData name="Rich Reba" userId="55db41ab6eb3f845" providerId="LiveId" clId="{0E19DA16-244C-5B50-BE0F-52911DD4CA7E}" dt="2026-08-10T12:07:12.357" v="525" actId="478"/>
         <pc:sldMkLst>
           <pc:docMk/>
           <pc:sldMk cId="4015092339" sldId="418"/>
         </pc:sldMkLst>
+        <pc:spChg chg="del">
+          <ac:chgData name="Rich Reba" userId="55db41ab6eb3f845" providerId="LiveId" clId="{0E19DA16-244C-5B50-BE0F-52911DD4CA7E}" dt="2026-08-10T12:07:12.357" v="525" actId="478"/>
+          <ac:spMkLst>
+            <pc:docMk/>
+            <pc:sldMk cId="4015092339" sldId="418"/>
+            <ac:spMk id="2" creationId="{462B9D62-4B92-3A8C-DA14-A225E2194D1F}"/>
+          </ac:spMkLst>
+        </pc:spChg>
         <pc:graphicFrameChg chg="modGraphic">
           <ac:chgData name="Rich Reba" userId="55db41ab6eb3f845" providerId="LiveId" clId="{0E19DA16-244C-5B50-BE0F-52911DD4CA7E}" dt="2026-08-06T16:28:21.663" v="199" actId="20577"/>
           <ac:graphicFrameMkLst>
@@ -384,12 +431,20 @@
           </ac:graphicFrameMkLst>
         </pc:graphicFrameChg>
       </pc:sldChg>
-      <pc:sldChg chg="modSp mod">
-        <pc:chgData name="Rich Reba" userId="55db41ab6eb3f845" providerId="LiveId" clId="{0E19DA16-244C-5B50-BE0F-52911DD4CA7E}" dt="2026-08-06T16:29:27.860" v="215" actId="20577"/>
+      <pc:sldChg chg="delSp modSp mod">
+        <pc:chgData name="Rich Reba" userId="55db41ab6eb3f845" providerId="LiveId" clId="{0E19DA16-244C-5B50-BE0F-52911DD4CA7E}" dt="2026-08-10T12:07:16.759" v="526" actId="478"/>
         <pc:sldMkLst>
           <pc:docMk/>
           <pc:sldMk cId="3381750306" sldId="419"/>
         </pc:sldMkLst>
+        <pc:spChg chg="del">
+          <ac:chgData name="Rich Reba" userId="55db41ab6eb3f845" providerId="LiveId" clId="{0E19DA16-244C-5B50-BE0F-52911DD4CA7E}" dt="2026-08-10T12:07:16.759" v="526" actId="478"/>
+          <ac:spMkLst>
+            <pc:docMk/>
+            <pc:sldMk cId="3381750306" sldId="419"/>
+            <ac:spMk id="2" creationId="{A837E304-B0E0-78B0-2263-1A31EE4658E7}"/>
+          </ac:spMkLst>
+        </pc:spChg>
         <pc:graphicFrameChg chg="modGraphic">
           <ac:chgData name="Rich Reba" userId="55db41ab6eb3f845" providerId="LiveId" clId="{0E19DA16-244C-5B50-BE0F-52911DD4CA7E}" dt="2026-08-06T16:29:27.860" v="215" actId="20577"/>
           <ac:graphicFrameMkLst>
@@ -399,12 +454,20 @@
           </ac:graphicFrameMkLst>
         </pc:graphicFrameChg>
       </pc:sldChg>
-      <pc:sldChg chg="modSp mod">
-        <pc:chgData name="Rich Reba" userId="55db41ab6eb3f845" providerId="LiveId" clId="{0E19DA16-244C-5B50-BE0F-52911DD4CA7E}" dt="2026-08-06T16:31:55.906" v="324" actId="20577"/>
+      <pc:sldChg chg="delSp modSp mod">
+        <pc:chgData name="Rich Reba" userId="55db41ab6eb3f845" providerId="LiveId" clId="{0E19DA16-244C-5B50-BE0F-52911DD4CA7E}" dt="2026-08-10T12:07:20.066" v="527" actId="478"/>
         <pc:sldMkLst>
           <pc:docMk/>
           <pc:sldMk cId="4209041106" sldId="420"/>
         </pc:sldMkLst>
+        <pc:spChg chg="del">
+          <ac:chgData name="Rich Reba" userId="55db41ab6eb3f845" providerId="LiveId" clId="{0E19DA16-244C-5B50-BE0F-52911DD4CA7E}" dt="2026-08-10T12:07:20.066" v="527" actId="478"/>
+          <ac:spMkLst>
+            <pc:docMk/>
+            <pc:sldMk cId="4209041106" sldId="420"/>
+            <ac:spMk id="2" creationId="{7FEDDB3B-2B33-FC16-9957-17D50DC8B784}"/>
+          </ac:spMkLst>
+        </pc:spChg>
         <pc:graphicFrameChg chg="mod modGraphic">
           <ac:chgData name="Rich Reba" userId="55db41ab6eb3f845" providerId="LiveId" clId="{0E19DA16-244C-5B50-BE0F-52911DD4CA7E}" dt="2026-08-06T16:31:55.906" v="324" actId="20577"/>
           <ac:graphicFrameMkLst>
@@ -414,12 +477,20 @@
           </ac:graphicFrameMkLst>
         </pc:graphicFrameChg>
       </pc:sldChg>
-      <pc:sldChg chg="modSp mod">
-        <pc:chgData name="Rich Reba" userId="55db41ab6eb3f845" providerId="LiveId" clId="{0E19DA16-244C-5B50-BE0F-52911DD4CA7E}" dt="2026-08-06T16:33:58.650" v="466" actId="20577"/>
+      <pc:sldChg chg="delSp modSp mod">
+        <pc:chgData name="Rich Reba" userId="55db41ab6eb3f845" providerId="LiveId" clId="{0E19DA16-244C-5B50-BE0F-52911DD4CA7E}" dt="2026-08-10T12:07:07.331" v="524" actId="478"/>
         <pc:sldMkLst>
           <pc:docMk/>
           <pc:sldMk cId="3765181648" sldId="421"/>
         </pc:sldMkLst>
+        <pc:spChg chg="del">
+          <ac:chgData name="Rich Reba" userId="55db41ab6eb3f845" providerId="LiveId" clId="{0E19DA16-244C-5B50-BE0F-52911DD4CA7E}" dt="2026-08-10T12:07:07.331" v="524" actId="478"/>
+          <ac:spMkLst>
+            <pc:docMk/>
+            <pc:sldMk cId="3765181648" sldId="421"/>
+            <ac:spMk id="2" creationId="{581D35DC-2D2E-4B81-D251-A66615F9BC3C}"/>
+          </ac:spMkLst>
+        </pc:spChg>
         <pc:graphicFrameChg chg="mod modGraphic">
           <ac:chgData name="Rich Reba" userId="55db41ab6eb3f845" providerId="LiveId" clId="{0E19DA16-244C-5B50-BE0F-52911DD4CA7E}" dt="2026-08-06T16:33:58.650" v="466" actId="20577"/>
           <ac:graphicFrameMkLst>
@@ -11924,221 +11995,6 @@
           </a:p>
         </p:txBody>
       </p:sp>
-      <p:sp>
-        <p:nvSpPr>
-          <p:cNvPr id="2" name="Google Shape;9;p8">
-            <a:extLst>
-              <a:ext uri="{FF2B5EF4-FFF2-40B4-BE49-F238E27FC236}">
-                <a16:creationId xmlns:a16="http://schemas.microsoft.com/office/drawing/2014/main" id="{00C41C28-1F72-7447-74D3-F57B36646C52}"/>
-              </a:ext>
-            </a:extLst>
-          </p:cNvPr>
-          <p:cNvSpPr txBox="1">
-            <a:spLocks noGrp="1"/>
-          </p:cNvSpPr>
-          <p:nvPr>
-            <p:ph type="ftr" idx="11"/>
-          </p:nvPr>
-        </p:nvSpPr>
-        <p:spPr>
-          <a:xfrm>
-            <a:off x="4038600" y="6356350"/>
-            <a:ext cx="4114800" cy="365125"/>
-          </a:xfrm>
-          <a:prstGeom prst="rect">
-            <a:avLst/>
-          </a:prstGeom>
-          <a:noFill/>
-          <a:ln>
-            <a:noFill/>
-          </a:ln>
-        </p:spPr>
-        <p:txBody>
-          <a:bodyPr spcFirstLastPara="1" wrap="square" lIns="91425" tIns="45700" rIns="91425" bIns="45700" anchor="ctr" anchorCtr="0">
-            <a:noAutofit/>
-          </a:bodyPr>
-          <a:lstStyle>
-            <a:lvl1pPr marR="0" lvl="0" algn="ctr" rtl="0">
-              <a:spcBef>
-                <a:spcPts val="0"/>
-              </a:spcBef>
-              <a:spcAft>
-                <a:spcPts val="0"/>
-              </a:spcAft>
-              <a:buSzPts val="1400"/>
-              <a:buNone/>
-              <a:defRPr sz="1200" b="0" i="0" u="none" strike="noStrike" cap="none">
-                <a:solidFill>
-                  <a:srgbClr val="888888"/>
-                </a:solidFill>
-                <a:latin typeface="Calibri"/>
-                <a:ea typeface="Calibri"/>
-                <a:cs typeface="Calibri"/>
-                <a:sym typeface="Calibri"/>
-              </a:defRPr>
-            </a:lvl1pPr>
-            <a:lvl2pPr marR="0" lvl="1" algn="l" rtl="0">
-              <a:spcBef>
-                <a:spcPts val="0"/>
-              </a:spcBef>
-              <a:spcAft>
-                <a:spcPts val="0"/>
-              </a:spcAft>
-              <a:buSzPts val="1400"/>
-              <a:buNone/>
-              <a:defRPr sz="1800" b="0" i="0" u="none" strike="noStrike" cap="none">
-                <a:solidFill>
-                  <a:schemeClr val="dk1"/>
-                </a:solidFill>
-                <a:latin typeface="Calibri"/>
-                <a:ea typeface="Calibri"/>
-                <a:cs typeface="Calibri"/>
-                <a:sym typeface="Calibri"/>
-              </a:defRPr>
-            </a:lvl2pPr>
-            <a:lvl3pPr marR="0" lvl="2" algn="l" rtl="0">
-              <a:spcBef>
-                <a:spcPts val="0"/>
-              </a:spcBef>
-              <a:spcAft>
-                <a:spcPts val="0"/>
-              </a:spcAft>
-              <a:buSzPts val="1400"/>
-              <a:buNone/>
-              <a:defRPr sz="1800" b="0" i="0" u="none" strike="noStrike" cap="none">
-                <a:solidFill>
-                  <a:schemeClr val="dk1"/>
-                </a:solidFill>
-                <a:latin typeface="Calibri"/>
-                <a:ea typeface="Calibri"/>
-                <a:cs typeface="Calibri"/>
-                <a:sym typeface="Calibri"/>
-              </a:defRPr>
-            </a:lvl3pPr>
-            <a:lvl4pPr marR="0" lvl="3" algn="l" rtl="0">
-              <a:spcBef>
-                <a:spcPts val="0"/>
-              </a:spcBef>
-              <a:spcAft>
-                <a:spcPts val="0"/>
-              </a:spcAft>
-              <a:buSzPts val="1400"/>
-              <a:buNone/>
-              <a:defRPr sz="1800" b="0" i="0" u="none" strike="noStrike" cap="none">
-                <a:solidFill>
-                  <a:schemeClr val="dk1"/>
-                </a:solidFill>
-                <a:latin typeface="Calibri"/>
-                <a:ea typeface="Calibri"/>
-                <a:cs typeface="Calibri"/>
-                <a:sym typeface="Calibri"/>
-              </a:defRPr>
-            </a:lvl4pPr>
-            <a:lvl5pPr marR="0" lvl="4" algn="l" rtl="0">
-              <a:spcBef>
-                <a:spcPts val="0"/>
-              </a:spcBef>
-              <a:spcAft>
-                <a:spcPts val="0"/>
-              </a:spcAft>
-              <a:buSzPts val="1400"/>
-              <a:buNone/>
-              <a:defRPr sz="1800" b="0" i="0" u="none" strike="noStrike" cap="none">
-                <a:solidFill>
-                  <a:schemeClr val="dk1"/>
-                </a:solidFill>
-                <a:latin typeface="Calibri"/>
-                <a:ea typeface="Calibri"/>
-                <a:cs typeface="Calibri"/>
-                <a:sym typeface="Calibri"/>
-              </a:defRPr>
-            </a:lvl5pPr>
-            <a:lvl6pPr marR="0" lvl="5" algn="l" rtl="0">
-              <a:spcBef>
-                <a:spcPts val="0"/>
-              </a:spcBef>
-              <a:spcAft>
-                <a:spcPts val="0"/>
-              </a:spcAft>
-              <a:buSzPts val="1400"/>
-              <a:buNone/>
-              <a:defRPr sz="1800" b="0" i="0" u="none" strike="noStrike" cap="none">
-                <a:solidFill>
-                  <a:schemeClr val="dk1"/>
-                </a:solidFill>
-                <a:latin typeface="Calibri"/>
-                <a:ea typeface="Calibri"/>
-                <a:cs typeface="Calibri"/>
-                <a:sym typeface="Calibri"/>
-              </a:defRPr>
-            </a:lvl6pPr>
-            <a:lvl7pPr marR="0" lvl="6" algn="l" rtl="0">
-              <a:spcBef>
-                <a:spcPts val="0"/>
-              </a:spcBef>
-              <a:spcAft>
-                <a:spcPts val="0"/>
-              </a:spcAft>
-              <a:buSzPts val="1400"/>
-              <a:buNone/>
-              <a:defRPr sz="1800" b="0" i="0" u="none" strike="noStrike" cap="none">
-                <a:solidFill>
-                  <a:schemeClr val="dk1"/>
-                </a:solidFill>
-                <a:latin typeface="Calibri"/>
-                <a:ea typeface="Calibri"/>
-                <a:cs typeface="Calibri"/>
-                <a:sym typeface="Calibri"/>
-              </a:defRPr>
-            </a:lvl7pPr>
-            <a:lvl8pPr marR="0" lvl="7" algn="l" rtl="0">
-              <a:spcBef>
-                <a:spcPts val="0"/>
-              </a:spcBef>
-              <a:spcAft>
-                <a:spcPts val="0"/>
-              </a:spcAft>
-              <a:buSzPts val="1400"/>
-              <a:buNone/>
-              <a:defRPr sz="1800" b="0" i="0" u="none" strike="noStrike" cap="none">
-                <a:solidFill>
-                  <a:schemeClr val="dk1"/>
-                </a:solidFill>
-                <a:latin typeface="Calibri"/>
-                <a:ea typeface="Calibri"/>
-                <a:cs typeface="Calibri"/>
-                <a:sym typeface="Calibri"/>
-              </a:defRPr>
-            </a:lvl8pPr>
-            <a:lvl9pPr marR="0" lvl="8" algn="l" rtl="0">
-              <a:spcBef>
-                <a:spcPts val="0"/>
-              </a:spcBef>
-              <a:spcAft>
-                <a:spcPts val="0"/>
-              </a:spcAft>
-              <a:buSzPts val="1400"/>
-              <a:buNone/>
-              <a:defRPr sz="1800" b="0" i="0" u="none" strike="noStrike" cap="none">
-                <a:solidFill>
-                  <a:schemeClr val="dk1"/>
-                </a:solidFill>
-                <a:latin typeface="Calibri"/>
-                <a:ea typeface="Calibri"/>
-                <a:cs typeface="Calibri"/>
-                <a:sym typeface="Calibri"/>
-              </a:defRPr>
-            </a:lvl9pPr>
-          </a:lstStyle>
-          <a:p>
-            <a:r>
-              <a:rPr lang="en-US" dirty="0"/>
-              <a:t>Proprietary and Confidential Information</a:t>
-            </a:r>
-            <a:endParaRPr dirty="0"/>
-          </a:p>
-        </p:txBody>
-      </p:sp>
     </p:spTree>
   </p:cSld>
   <p:clrMapOvr>
@@ -12382,221 +12238,6 @@
             <a:r>
               <a:rPr lang="en-US" dirty="0"/>
               <a:t>Finance &amp; Responsibility</a:t>
-            </a:r>
-            <a:endParaRPr dirty="0"/>
-          </a:p>
-        </p:txBody>
-      </p:sp>
-      <p:sp>
-        <p:nvSpPr>
-          <p:cNvPr id="2" name="Google Shape;9;p8">
-            <a:extLst>
-              <a:ext uri="{FF2B5EF4-FFF2-40B4-BE49-F238E27FC236}">
-                <a16:creationId xmlns:a16="http://schemas.microsoft.com/office/drawing/2014/main" id="{2F16A1F0-E195-BF45-032B-42BF906BEC9A}"/>
-              </a:ext>
-            </a:extLst>
-          </p:cNvPr>
-          <p:cNvSpPr txBox="1">
-            <a:spLocks noGrp="1"/>
-          </p:cNvSpPr>
-          <p:nvPr>
-            <p:ph type="ftr" idx="11"/>
-          </p:nvPr>
-        </p:nvSpPr>
-        <p:spPr>
-          <a:xfrm>
-            <a:off x="4038600" y="6356350"/>
-            <a:ext cx="4114800" cy="365125"/>
-          </a:xfrm>
-          <a:prstGeom prst="rect">
-            <a:avLst/>
-          </a:prstGeom>
-          <a:noFill/>
-          <a:ln>
-            <a:noFill/>
-          </a:ln>
-        </p:spPr>
-        <p:txBody>
-          <a:bodyPr spcFirstLastPara="1" wrap="square" lIns="91425" tIns="45700" rIns="91425" bIns="45700" anchor="ctr" anchorCtr="0">
-            <a:noAutofit/>
-          </a:bodyPr>
-          <a:lstStyle>
-            <a:lvl1pPr marR="0" lvl="0" algn="ctr" rtl="0">
-              <a:spcBef>
-                <a:spcPts val="0"/>
-              </a:spcBef>
-              <a:spcAft>
-                <a:spcPts val="0"/>
-              </a:spcAft>
-              <a:buSzPts val="1400"/>
-              <a:buNone/>
-              <a:defRPr sz="1200" b="0" i="0" u="none" strike="noStrike" cap="none">
-                <a:solidFill>
-                  <a:srgbClr val="888888"/>
-                </a:solidFill>
-                <a:latin typeface="Calibri"/>
-                <a:ea typeface="Calibri"/>
-                <a:cs typeface="Calibri"/>
-                <a:sym typeface="Calibri"/>
-              </a:defRPr>
-            </a:lvl1pPr>
-            <a:lvl2pPr marR="0" lvl="1" algn="l" rtl="0">
-              <a:spcBef>
-                <a:spcPts val="0"/>
-              </a:spcBef>
-              <a:spcAft>
-                <a:spcPts val="0"/>
-              </a:spcAft>
-              <a:buSzPts val="1400"/>
-              <a:buNone/>
-              <a:defRPr sz="1800" b="0" i="0" u="none" strike="noStrike" cap="none">
-                <a:solidFill>
-                  <a:schemeClr val="dk1"/>
-                </a:solidFill>
-                <a:latin typeface="Calibri"/>
-                <a:ea typeface="Calibri"/>
-                <a:cs typeface="Calibri"/>
-                <a:sym typeface="Calibri"/>
-              </a:defRPr>
-            </a:lvl2pPr>
-            <a:lvl3pPr marR="0" lvl="2" algn="l" rtl="0">
-              <a:spcBef>
-                <a:spcPts val="0"/>
-              </a:spcBef>
-              <a:spcAft>
-                <a:spcPts val="0"/>
-              </a:spcAft>
-              <a:buSzPts val="1400"/>
-              <a:buNone/>
-              <a:defRPr sz="1800" b="0" i="0" u="none" strike="noStrike" cap="none">
-                <a:solidFill>
-                  <a:schemeClr val="dk1"/>
-                </a:solidFill>
-                <a:latin typeface="Calibri"/>
-                <a:ea typeface="Calibri"/>
-                <a:cs typeface="Calibri"/>
-                <a:sym typeface="Calibri"/>
-              </a:defRPr>
-            </a:lvl3pPr>
-            <a:lvl4pPr marR="0" lvl="3" algn="l" rtl="0">
-              <a:spcBef>
-                <a:spcPts val="0"/>
-              </a:spcBef>
-              <a:spcAft>
-                <a:spcPts val="0"/>
-              </a:spcAft>
-              <a:buSzPts val="1400"/>
-              <a:buNone/>
-              <a:defRPr sz="1800" b="0" i="0" u="none" strike="noStrike" cap="none">
-                <a:solidFill>
-                  <a:schemeClr val="dk1"/>
-                </a:solidFill>
-                <a:latin typeface="Calibri"/>
-                <a:ea typeface="Calibri"/>
-                <a:cs typeface="Calibri"/>
-                <a:sym typeface="Calibri"/>
-              </a:defRPr>
-            </a:lvl4pPr>
-            <a:lvl5pPr marR="0" lvl="4" algn="l" rtl="0">
-              <a:spcBef>
-                <a:spcPts val="0"/>
-              </a:spcBef>
-              <a:spcAft>
-                <a:spcPts val="0"/>
-              </a:spcAft>
-              <a:buSzPts val="1400"/>
-              <a:buNone/>
-              <a:defRPr sz="1800" b="0" i="0" u="none" strike="noStrike" cap="none">
-                <a:solidFill>
-                  <a:schemeClr val="dk1"/>
-                </a:solidFill>
-                <a:latin typeface="Calibri"/>
-                <a:ea typeface="Calibri"/>
-                <a:cs typeface="Calibri"/>
-                <a:sym typeface="Calibri"/>
-              </a:defRPr>
-            </a:lvl5pPr>
-            <a:lvl6pPr marR="0" lvl="5" algn="l" rtl="0">
-              <a:spcBef>
-                <a:spcPts val="0"/>
-              </a:spcBef>
-              <a:spcAft>
-                <a:spcPts val="0"/>
-              </a:spcAft>
-              <a:buSzPts val="1400"/>
-              <a:buNone/>
-              <a:defRPr sz="1800" b="0" i="0" u="none" strike="noStrike" cap="none">
-                <a:solidFill>
-                  <a:schemeClr val="dk1"/>
-                </a:solidFill>
-                <a:latin typeface="Calibri"/>
-                <a:ea typeface="Calibri"/>
-                <a:cs typeface="Calibri"/>
-                <a:sym typeface="Calibri"/>
-              </a:defRPr>
-            </a:lvl6pPr>
-            <a:lvl7pPr marR="0" lvl="6" algn="l" rtl="0">
-              <a:spcBef>
-                <a:spcPts val="0"/>
-              </a:spcBef>
-              <a:spcAft>
-                <a:spcPts val="0"/>
-              </a:spcAft>
-              <a:buSzPts val="1400"/>
-              <a:buNone/>
-              <a:defRPr sz="1800" b="0" i="0" u="none" strike="noStrike" cap="none">
-                <a:solidFill>
-                  <a:schemeClr val="dk1"/>
-                </a:solidFill>
-                <a:latin typeface="Calibri"/>
-                <a:ea typeface="Calibri"/>
-                <a:cs typeface="Calibri"/>
-                <a:sym typeface="Calibri"/>
-              </a:defRPr>
-            </a:lvl7pPr>
-            <a:lvl8pPr marR="0" lvl="7" algn="l" rtl="0">
-              <a:spcBef>
-                <a:spcPts val="0"/>
-              </a:spcBef>
-              <a:spcAft>
-                <a:spcPts val="0"/>
-              </a:spcAft>
-              <a:buSzPts val="1400"/>
-              <a:buNone/>
-              <a:defRPr sz="1800" b="0" i="0" u="none" strike="noStrike" cap="none">
-                <a:solidFill>
-                  <a:schemeClr val="dk1"/>
-                </a:solidFill>
-                <a:latin typeface="Calibri"/>
-                <a:ea typeface="Calibri"/>
-                <a:cs typeface="Calibri"/>
-                <a:sym typeface="Calibri"/>
-              </a:defRPr>
-            </a:lvl8pPr>
-            <a:lvl9pPr marR="0" lvl="8" algn="l" rtl="0">
-              <a:spcBef>
-                <a:spcPts val="0"/>
-              </a:spcBef>
-              <a:spcAft>
-                <a:spcPts val="0"/>
-              </a:spcAft>
-              <a:buSzPts val="1400"/>
-              <a:buNone/>
-              <a:defRPr sz="1800" b="0" i="0" u="none" strike="noStrike" cap="none">
-                <a:solidFill>
-                  <a:schemeClr val="dk1"/>
-                </a:solidFill>
-                <a:latin typeface="Calibri"/>
-                <a:ea typeface="Calibri"/>
-                <a:cs typeface="Calibri"/>
-                <a:sym typeface="Calibri"/>
-              </a:defRPr>
-            </a:lvl9pPr>
-          </a:lstStyle>
-          <a:p>
-            <a:r>
-              <a:rPr lang="en-US" dirty="0"/>
-              <a:t>Proprietary and Confidential Information</a:t>
             </a:r>
             <a:endParaRPr dirty="0"/>
           </a:p>
@@ -12906,221 +12547,6 @@
           </a:p>
           <a:p>
             <a:endParaRPr lang="en-US" dirty="0"/>
-          </a:p>
-        </p:txBody>
-      </p:sp>
-      <p:sp>
-        <p:nvSpPr>
-          <p:cNvPr id="2" name="Google Shape;9;p8">
-            <a:extLst>
-              <a:ext uri="{FF2B5EF4-FFF2-40B4-BE49-F238E27FC236}">
-                <a16:creationId xmlns:a16="http://schemas.microsoft.com/office/drawing/2014/main" id="{4B602561-35D8-AF27-76E9-EB18F18FC081}"/>
-              </a:ext>
-            </a:extLst>
-          </p:cNvPr>
-          <p:cNvSpPr txBox="1">
-            <a:spLocks noGrp="1"/>
-          </p:cNvSpPr>
-          <p:nvPr>
-            <p:ph type="ftr" idx="11"/>
-          </p:nvPr>
-        </p:nvSpPr>
-        <p:spPr>
-          <a:xfrm>
-            <a:off x="4038600" y="6356350"/>
-            <a:ext cx="4114800" cy="365125"/>
-          </a:xfrm>
-          <a:prstGeom prst="rect">
-            <a:avLst/>
-          </a:prstGeom>
-          <a:noFill/>
-          <a:ln>
-            <a:noFill/>
-          </a:ln>
-        </p:spPr>
-        <p:txBody>
-          <a:bodyPr spcFirstLastPara="1" wrap="square" lIns="91425" tIns="45700" rIns="91425" bIns="45700" anchor="ctr" anchorCtr="0">
-            <a:noAutofit/>
-          </a:bodyPr>
-          <a:lstStyle>
-            <a:lvl1pPr marR="0" lvl="0" algn="ctr" rtl="0">
-              <a:spcBef>
-                <a:spcPts val="0"/>
-              </a:spcBef>
-              <a:spcAft>
-                <a:spcPts val="0"/>
-              </a:spcAft>
-              <a:buSzPts val="1400"/>
-              <a:buNone/>
-              <a:defRPr sz="1200" b="0" i="0" u="none" strike="noStrike" cap="none">
-                <a:solidFill>
-                  <a:srgbClr val="888888"/>
-                </a:solidFill>
-                <a:latin typeface="Calibri"/>
-                <a:ea typeface="Calibri"/>
-                <a:cs typeface="Calibri"/>
-                <a:sym typeface="Calibri"/>
-              </a:defRPr>
-            </a:lvl1pPr>
-            <a:lvl2pPr marR="0" lvl="1" algn="l" rtl="0">
-              <a:spcBef>
-                <a:spcPts val="0"/>
-              </a:spcBef>
-              <a:spcAft>
-                <a:spcPts val="0"/>
-              </a:spcAft>
-              <a:buSzPts val="1400"/>
-              <a:buNone/>
-              <a:defRPr sz="1800" b="0" i="0" u="none" strike="noStrike" cap="none">
-                <a:solidFill>
-                  <a:schemeClr val="dk1"/>
-                </a:solidFill>
-                <a:latin typeface="Calibri"/>
-                <a:ea typeface="Calibri"/>
-                <a:cs typeface="Calibri"/>
-                <a:sym typeface="Calibri"/>
-              </a:defRPr>
-            </a:lvl2pPr>
-            <a:lvl3pPr marR="0" lvl="2" algn="l" rtl="0">
-              <a:spcBef>
-                <a:spcPts val="0"/>
-              </a:spcBef>
-              <a:spcAft>
-                <a:spcPts val="0"/>
-              </a:spcAft>
-              <a:buSzPts val="1400"/>
-              <a:buNone/>
-              <a:defRPr sz="1800" b="0" i="0" u="none" strike="noStrike" cap="none">
-                <a:solidFill>
-                  <a:schemeClr val="dk1"/>
-                </a:solidFill>
-                <a:latin typeface="Calibri"/>
-                <a:ea typeface="Calibri"/>
-                <a:cs typeface="Calibri"/>
-                <a:sym typeface="Calibri"/>
-              </a:defRPr>
-            </a:lvl3pPr>
-            <a:lvl4pPr marR="0" lvl="3" algn="l" rtl="0">
-              <a:spcBef>
-                <a:spcPts val="0"/>
-              </a:spcBef>
-              <a:spcAft>
-                <a:spcPts val="0"/>
-              </a:spcAft>
-              <a:buSzPts val="1400"/>
-              <a:buNone/>
-              <a:defRPr sz="1800" b="0" i="0" u="none" strike="noStrike" cap="none">
-                <a:solidFill>
-                  <a:schemeClr val="dk1"/>
-                </a:solidFill>
-                <a:latin typeface="Calibri"/>
-                <a:ea typeface="Calibri"/>
-                <a:cs typeface="Calibri"/>
-                <a:sym typeface="Calibri"/>
-              </a:defRPr>
-            </a:lvl4pPr>
-            <a:lvl5pPr marR="0" lvl="4" algn="l" rtl="0">
-              <a:spcBef>
-                <a:spcPts val="0"/>
-              </a:spcBef>
-              <a:spcAft>
-                <a:spcPts val="0"/>
-              </a:spcAft>
-              <a:buSzPts val="1400"/>
-              <a:buNone/>
-              <a:defRPr sz="1800" b="0" i="0" u="none" strike="noStrike" cap="none">
-                <a:solidFill>
-                  <a:schemeClr val="dk1"/>
-                </a:solidFill>
-                <a:latin typeface="Calibri"/>
-                <a:ea typeface="Calibri"/>
-                <a:cs typeface="Calibri"/>
-                <a:sym typeface="Calibri"/>
-              </a:defRPr>
-            </a:lvl5pPr>
-            <a:lvl6pPr marR="0" lvl="5" algn="l" rtl="0">
-              <a:spcBef>
-                <a:spcPts val="0"/>
-              </a:spcBef>
-              <a:spcAft>
-                <a:spcPts val="0"/>
-              </a:spcAft>
-              <a:buSzPts val="1400"/>
-              <a:buNone/>
-              <a:defRPr sz="1800" b="0" i="0" u="none" strike="noStrike" cap="none">
-                <a:solidFill>
-                  <a:schemeClr val="dk1"/>
-                </a:solidFill>
-                <a:latin typeface="Calibri"/>
-                <a:ea typeface="Calibri"/>
-                <a:cs typeface="Calibri"/>
-                <a:sym typeface="Calibri"/>
-              </a:defRPr>
-            </a:lvl6pPr>
-            <a:lvl7pPr marR="0" lvl="6" algn="l" rtl="0">
-              <a:spcBef>
-                <a:spcPts val="0"/>
-              </a:spcBef>
-              <a:spcAft>
-                <a:spcPts val="0"/>
-              </a:spcAft>
-              <a:buSzPts val="1400"/>
-              <a:buNone/>
-              <a:defRPr sz="1800" b="0" i="0" u="none" strike="noStrike" cap="none">
-                <a:solidFill>
-                  <a:schemeClr val="dk1"/>
-                </a:solidFill>
-                <a:latin typeface="Calibri"/>
-                <a:ea typeface="Calibri"/>
-                <a:cs typeface="Calibri"/>
-                <a:sym typeface="Calibri"/>
-              </a:defRPr>
-            </a:lvl7pPr>
-            <a:lvl8pPr marR="0" lvl="7" algn="l" rtl="0">
-              <a:spcBef>
-                <a:spcPts val="0"/>
-              </a:spcBef>
-              <a:spcAft>
-                <a:spcPts val="0"/>
-              </a:spcAft>
-              <a:buSzPts val="1400"/>
-              <a:buNone/>
-              <a:defRPr sz="1800" b="0" i="0" u="none" strike="noStrike" cap="none">
-                <a:solidFill>
-                  <a:schemeClr val="dk1"/>
-                </a:solidFill>
-                <a:latin typeface="Calibri"/>
-                <a:ea typeface="Calibri"/>
-                <a:cs typeface="Calibri"/>
-                <a:sym typeface="Calibri"/>
-              </a:defRPr>
-            </a:lvl8pPr>
-            <a:lvl9pPr marR="0" lvl="8" algn="l" rtl="0">
-              <a:spcBef>
-                <a:spcPts val="0"/>
-              </a:spcBef>
-              <a:spcAft>
-                <a:spcPts val="0"/>
-              </a:spcAft>
-              <a:buSzPts val="1400"/>
-              <a:buNone/>
-              <a:defRPr sz="1800" b="0" i="0" u="none" strike="noStrike" cap="none">
-                <a:solidFill>
-                  <a:schemeClr val="dk1"/>
-                </a:solidFill>
-                <a:latin typeface="Calibri"/>
-                <a:ea typeface="Calibri"/>
-                <a:cs typeface="Calibri"/>
-                <a:sym typeface="Calibri"/>
-              </a:defRPr>
-            </a:lvl9pPr>
-          </a:lstStyle>
-          <a:p>
-            <a:r>
-              <a:rPr lang="en-US" dirty="0"/>
-              <a:t>Proprietary and Confidential Information</a:t>
-            </a:r>
-            <a:endParaRPr dirty="0"/>
           </a:p>
         </p:txBody>
       </p:sp>
@@ -14581,221 +14007,6 @@
               </a:rPr>
               <a:t>Innovation</a:t>
             </a:r>
-          </a:p>
-        </p:txBody>
-      </p:sp>
-      <p:sp>
-        <p:nvSpPr>
-          <p:cNvPr id="6" name="Google Shape;9;p8">
-            <a:extLst>
-              <a:ext uri="{FF2B5EF4-FFF2-40B4-BE49-F238E27FC236}">
-                <a16:creationId xmlns:a16="http://schemas.microsoft.com/office/drawing/2014/main" id="{CF348359-6A33-94C2-7023-E826A712A5B3}"/>
-              </a:ext>
-            </a:extLst>
-          </p:cNvPr>
-          <p:cNvSpPr txBox="1">
-            <a:spLocks noGrp="1"/>
-          </p:cNvSpPr>
-          <p:nvPr>
-            <p:ph type="ftr" idx="11"/>
-          </p:nvPr>
-        </p:nvSpPr>
-        <p:spPr>
-          <a:xfrm>
-            <a:off x="4038600" y="6356350"/>
-            <a:ext cx="4114800" cy="365125"/>
-          </a:xfrm>
-          <a:prstGeom prst="rect">
-            <a:avLst/>
-          </a:prstGeom>
-          <a:noFill/>
-          <a:ln>
-            <a:noFill/>
-          </a:ln>
-        </p:spPr>
-        <p:txBody>
-          <a:bodyPr spcFirstLastPara="1" wrap="square" lIns="91425" tIns="45700" rIns="91425" bIns="45700" anchor="ctr" anchorCtr="0">
-            <a:noAutofit/>
-          </a:bodyPr>
-          <a:lstStyle>
-            <a:lvl1pPr marR="0" lvl="0" algn="ctr" rtl="0">
-              <a:spcBef>
-                <a:spcPts val="0"/>
-              </a:spcBef>
-              <a:spcAft>
-                <a:spcPts val="0"/>
-              </a:spcAft>
-              <a:buSzPts val="1400"/>
-              <a:buNone/>
-              <a:defRPr sz="1200" b="0" i="0" u="none" strike="noStrike" cap="none">
-                <a:solidFill>
-                  <a:srgbClr val="888888"/>
-                </a:solidFill>
-                <a:latin typeface="Calibri"/>
-                <a:ea typeface="Calibri"/>
-                <a:cs typeface="Calibri"/>
-                <a:sym typeface="Calibri"/>
-              </a:defRPr>
-            </a:lvl1pPr>
-            <a:lvl2pPr marR="0" lvl="1" algn="l" rtl="0">
-              <a:spcBef>
-                <a:spcPts val="0"/>
-              </a:spcBef>
-              <a:spcAft>
-                <a:spcPts val="0"/>
-              </a:spcAft>
-              <a:buSzPts val="1400"/>
-              <a:buNone/>
-              <a:defRPr sz="1800" b="0" i="0" u="none" strike="noStrike" cap="none">
-                <a:solidFill>
-                  <a:schemeClr val="dk1"/>
-                </a:solidFill>
-                <a:latin typeface="Calibri"/>
-                <a:ea typeface="Calibri"/>
-                <a:cs typeface="Calibri"/>
-                <a:sym typeface="Calibri"/>
-              </a:defRPr>
-            </a:lvl2pPr>
-            <a:lvl3pPr marR="0" lvl="2" algn="l" rtl="0">
-              <a:spcBef>
-                <a:spcPts val="0"/>
-              </a:spcBef>
-              <a:spcAft>
-                <a:spcPts val="0"/>
-              </a:spcAft>
-              <a:buSzPts val="1400"/>
-              <a:buNone/>
-              <a:defRPr sz="1800" b="0" i="0" u="none" strike="noStrike" cap="none">
-                <a:solidFill>
-                  <a:schemeClr val="dk1"/>
-                </a:solidFill>
-                <a:latin typeface="Calibri"/>
-                <a:ea typeface="Calibri"/>
-                <a:cs typeface="Calibri"/>
-                <a:sym typeface="Calibri"/>
-              </a:defRPr>
-            </a:lvl3pPr>
-            <a:lvl4pPr marR="0" lvl="3" algn="l" rtl="0">
-              <a:spcBef>
-                <a:spcPts val="0"/>
-              </a:spcBef>
-              <a:spcAft>
-                <a:spcPts val="0"/>
-              </a:spcAft>
-              <a:buSzPts val="1400"/>
-              <a:buNone/>
-              <a:defRPr sz="1800" b="0" i="0" u="none" strike="noStrike" cap="none">
-                <a:solidFill>
-                  <a:schemeClr val="dk1"/>
-                </a:solidFill>
-                <a:latin typeface="Calibri"/>
-                <a:ea typeface="Calibri"/>
-                <a:cs typeface="Calibri"/>
-                <a:sym typeface="Calibri"/>
-              </a:defRPr>
-            </a:lvl4pPr>
-            <a:lvl5pPr marR="0" lvl="4" algn="l" rtl="0">
-              <a:spcBef>
-                <a:spcPts val="0"/>
-              </a:spcBef>
-              <a:spcAft>
-                <a:spcPts val="0"/>
-              </a:spcAft>
-              <a:buSzPts val="1400"/>
-              <a:buNone/>
-              <a:defRPr sz="1800" b="0" i="0" u="none" strike="noStrike" cap="none">
-                <a:solidFill>
-                  <a:schemeClr val="dk1"/>
-                </a:solidFill>
-                <a:latin typeface="Calibri"/>
-                <a:ea typeface="Calibri"/>
-                <a:cs typeface="Calibri"/>
-                <a:sym typeface="Calibri"/>
-              </a:defRPr>
-            </a:lvl5pPr>
-            <a:lvl6pPr marR="0" lvl="5" algn="l" rtl="0">
-              <a:spcBef>
-                <a:spcPts val="0"/>
-              </a:spcBef>
-              <a:spcAft>
-                <a:spcPts val="0"/>
-              </a:spcAft>
-              <a:buSzPts val="1400"/>
-              <a:buNone/>
-              <a:defRPr sz="1800" b="0" i="0" u="none" strike="noStrike" cap="none">
-                <a:solidFill>
-                  <a:schemeClr val="dk1"/>
-                </a:solidFill>
-                <a:latin typeface="Calibri"/>
-                <a:ea typeface="Calibri"/>
-                <a:cs typeface="Calibri"/>
-                <a:sym typeface="Calibri"/>
-              </a:defRPr>
-            </a:lvl6pPr>
-            <a:lvl7pPr marR="0" lvl="6" algn="l" rtl="0">
-              <a:spcBef>
-                <a:spcPts val="0"/>
-              </a:spcBef>
-              <a:spcAft>
-                <a:spcPts val="0"/>
-              </a:spcAft>
-              <a:buSzPts val="1400"/>
-              <a:buNone/>
-              <a:defRPr sz="1800" b="0" i="0" u="none" strike="noStrike" cap="none">
-                <a:solidFill>
-                  <a:schemeClr val="dk1"/>
-                </a:solidFill>
-                <a:latin typeface="Calibri"/>
-                <a:ea typeface="Calibri"/>
-                <a:cs typeface="Calibri"/>
-                <a:sym typeface="Calibri"/>
-              </a:defRPr>
-            </a:lvl7pPr>
-            <a:lvl8pPr marR="0" lvl="7" algn="l" rtl="0">
-              <a:spcBef>
-                <a:spcPts val="0"/>
-              </a:spcBef>
-              <a:spcAft>
-                <a:spcPts val="0"/>
-              </a:spcAft>
-              <a:buSzPts val="1400"/>
-              <a:buNone/>
-              <a:defRPr sz="1800" b="0" i="0" u="none" strike="noStrike" cap="none">
-                <a:solidFill>
-                  <a:schemeClr val="dk1"/>
-                </a:solidFill>
-                <a:latin typeface="Calibri"/>
-                <a:ea typeface="Calibri"/>
-                <a:cs typeface="Calibri"/>
-                <a:sym typeface="Calibri"/>
-              </a:defRPr>
-            </a:lvl8pPr>
-            <a:lvl9pPr marR="0" lvl="8" algn="l" rtl="0">
-              <a:spcBef>
-                <a:spcPts val="0"/>
-              </a:spcBef>
-              <a:spcAft>
-                <a:spcPts val="0"/>
-              </a:spcAft>
-              <a:buSzPts val="1400"/>
-              <a:buNone/>
-              <a:defRPr sz="1800" b="0" i="0" u="none" strike="noStrike" cap="none">
-                <a:solidFill>
-                  <a:schemeClr val="dk1"/>
-                </a:solidFill>
-                <a:latin typeface="Calibri"/>
-                <a:ea typeface="Calibri"/>
-                <a:cs typeface="Calibri"/>
-                <a:sym typeface="Calibri"/>
-              </a:defRPr>
-            </a:lvl9pPr>
-          </a:lstStyle>
-          <a:p>
-            <a:r>
-              <a:rPr lang="en-US" dirty="0"/>
-              <a:t>Proprietary and Confidential Information</a:t>
-            </a:r>
-            <a:endParaRPr dirty="0"/>
           </a:p>
         </p:txBody>
       </p:sp>
@@ -16380,194 +15591,6 @@
           </a:graphicData>
         </a:graphic>
       </p:graphicFrame>
-      <p:sp>
-        <p:nvSpPr>
-          <p:cNvPr id="2" name="Google Shape;18;p9">
-            <a:extLst>
-              <a:ext uri="{FF2B5EF4-FFF2-40B4-BE49-F238E27FC236}">
-                <a16:creationId xmlns:a16="http://schemas.microsoft.com/office/drawing/2014/main" id="{581D35DC-2D2E-4B81-D251-A66615F9BC3C}"/>
-              </a:ext>
-            </a:extLst>
-          </p:cNvPr>
-          <p:cNvSpPr txBox="1">
-            <a:spLocks noGrp="1"/>
-          </p:cNvSpPr>
-          <p:nvPr>
-            <p:ph type="ftr" idx="11"/>
-          </p:nvPr>
-        </p:nvSpPr>
-        <p:spPr>
-          <a:xfrm>
-            <a:off x="4038600" y="6356350"/>
-            <a:ext cx="4114800" cy="365125"/>
-          </a:xfrm>
-          <a:prstGeom prst="rect">
-            <a:avLst/>
-          </a:prstGeom>
-          <a:noFill/>
-          <a:ln>
-            <a:noFill/>
-          </a:ln>
-        </p:spPr>
-        <p:txBody>
-          <a:bodyPr spcFirstLastPara="1" wrap="square" lIns="91425" tIns="45700" rIns="91425" bIns="45700" anchor="ctr" anchorCtr="0">
-            <a:noAutofit/>
-          </a:bodyPr>
-          <a:lstStyle>
-            <a:lvl1pPr lvl="0" algn="ctr">
-              <a:spcBef>
-                <a:spcPts val="0"/>
-              </a:spcBef>
-              <a:spcAft>
-                <a:spcPts val="0"/>
-              </a:spcAft>
-              <a:buSzPts val="1400"/>
-              <a:buNone/>
-              <a:defRPr/>
-            </a:lvl1pPr>
-            <a:lvl2pPr lvl="1" algn="l">
-              <a:spcBef>
-                <a:spcPts val="0"/>
-              </a:spcBef>
-              <a:spcAft>
-                <a:spcPts val="0"/>
-              </a:spcAft>
-              <a:buSzPts val="1400"/>
-              <a:buNone/>
-              <a:defRPr/>
-            </a:lvl2pPr>
-            <a:lvl3pPr lvl="2" algn="l">
-              <a:spcBef>
-                <a:spcPts val="0"/>
-              </a:spcBef>
-              <a:spcAft>
-                <a:spcPts val="0"/>
-              </a:spcAft>
-              <a:buSzPts val="1400"/>
-              <a:buNone/>
-              <a:defRPr/>
-            </a:lvl3pPr>
-            <a:lvl4pPr lvl="3" algn="l">
-              <a:spcBef>
-                <a:spcPts val="0"/>
-              </a:spcBef>
-              <a:spcAft>
-                <a:spcPts val="0"/>
-              </a:spcAft>
-              <a:buSzPts val="1400"/>
-              <a:buNone/>
-              <a:defRPr/>
-            </a:lvl4pPr>
-            <a:lvl5pPr lvl="4" algn="l">
-              <a:spcBef>
-                <a:spcPts val="0"/>
-              </a:spcBef>
-              <a:spcAft>
-                <a:spcPts val="0"/>
-              </a:spcAft>
-              <a:buSzPts val="1400"/>
-              <a:buNone/>
-              <a:defRPr/>
-            </a:lvl5pPr>
-            <a:lvl6pPr lvl="5" algn="l">
-              <a:spcBef>
-                <a:spcPts val="0"/>
-              </a:spcBef>
-              <a:spcAft>
-                <a:spcPts val="0"/>
-              </a:spcAft>
-              <a:buSzPts val="1400"/>
-              <a:buNone/>
-              <a:defRPr/>
-            </a:lvl6pPr>
-            <a:lvl7pPr lvl="6" algn="l">
-              <a:spcBef>
-                <a:spcPts val="0"/>
-              </a:spcBef>
-              <a:spcAft>
-                <a:spcPts val="0"/>
-              </a:spcAft>
-              <a:buSzPts val="1400"/>
-              <a:buNone/>
-              <a:defRPr/>
-            </a:lvl7pPr>
-            <a:lvl8pPr lvl="7" algn="l">
-              <a:spcBef>
-                <a:spcPts val="0"/>
-              </a:spcBef>
-              <a:spcAft>
-                <a:spcPts val="0"/>
-              </a:spcAft>
-              <a:buSzPts val="1400"/>
-              <a:buNone/>
-              <a:defRPr/>
-            </a:lvl8pPr>
-            <a:lvl9pPr lvl="8" algn="l">
-              <a:spcBef>
-                <a:spcPts val="0"/>
-              </a:spcBef>
-              <a:spcAft>
-                <a:spcPts val="0"/>
-              </a:spcAft>
-              <a:buSzPts val="1400"/>
-              <a:buNone/>
-              <a:defRPr/>
-            </a:lvl9pPr>
-          </a:lstStyle>
-          <a:p>
-            <a:pPr marL="0" marR="0" lvl="0" indent="0" algn="ctr" defTabSz="914400" rtl="0" eaLnBrk="1" fontAlgn="auto" latinLnBrk="0" hangingPunct="1">
-              <a:lnSpc>
-                <a:spcPct val="100000"/>
-              </a:lnSpc>
-              <a:spcBef>
-                <a:spcPts val="0"/>
-              </a:spcBef>
-              <a:spcAft>
-                <a:spcPts val="0"/>
-              </a:spcAft>
-              <a:buClr>
-                <a:srgbClr val="000000"/>
-              </a:buClr>
-              <a:buSzPts val="1400"/>
-              <a:buFont typeface="Arial"/>
-              <a:buNone/>
-              <a:tabLst/>
-              <a:defRPr/>
-            </a:pPr>
-            <a:r>
-              <a:rPr kumimoji="0" lang="en-US" sz="1200" b="0" i="0" u="none" strike="noStrike" kern="0" cap="none" spc="0" normalizeH="0" baseline="0" noProof="0" dirty="0">
-                <a:ln>
-                  <a:noFill/>
-                </a:ln>
-                <a:solidFill>
-                  <a:srgbClr val="888888"/>
-                </a:solidFill>
-                <a:effectLst/>
-                <a:uLnTx/>
-                <a:uFillTx/>
-                <a:latin typeface="Calibri"/>
-                <a:cs typeface="Calibri"/>
-                <a:sym typeface="Calibri"/>
-              </a:rPr>
-              <a:t>Proprietary and Confidential Information</a:t>
-            </a:r>
-            <a:endParaRPr kumimoji="0" sz="1200" b="0" i="0" u="none" strike="noStrike" kern="0" cap="none" spc="0" normalizeH="0" baseline="0" noProof="0" dirty="0">
-              <a:ln>
-                <a:noFill/>
-              </a:ln>
-              <a:solidFill>
-                <a:srgbClr val="888888"/>
-              </a:solidFill>
-              <a:effectLst/>
-              <a:uLnTx/>
-              <a:uFillTx/>
-              <a:latin typeface="Calibri"/>
-              <a:cs typeface="Calibri"/>
-              <a:sym typeface="Calibri"/>
-            </a:endParaRPr>
-          </a:p>
-        </p:txBody>
-      </p:sp>
       <p:pic>
         <p:nvPicPr>
           <p:cNvPr id="3" name="Google Shape;110;p4" descr="Rich Reba">
@@ -17848,194 +16871,6 @@
           </a:graphicData>
         </a:graphic>
       </p:graphicFrame>
-      <p:sp>
-        <p:nvSpPr>
-          <p:cNvPr id="2" name="Google Shape;18;p9">
-            <a:extLst>
-              <a:ext uri="{FF2B5EF4-FFF2-40B4-BE49-F238E27FC236}">
-                <a16:creationId xmlns:a16="http://schemas.microsoft.com/office/drawing/2014/main" id="{462B9D62-4B92-3A8C-DA14-A225E2194D1F}"/>
-              </a:ext>
-            </a:extLst>
-          </p:cNvPr>
-          <p:cNvSpPr txBox="1">
-            <a:spLocks noGrp="1"/>
-          </p:cNvSpPr>
-          <p:nvPr>
-            <p:ph type="ftr" idx="11"/>
-          </p:nvPr>
-        </p:nvSpPr>
-        <p:spPr>
-          <a:xfrm>
-            <a:off x="4038600" y="6356350"/>
-            <a:ext cx="4114800" cy="365125"/>
-          </a:xfrm>
-          <a:prstGeom prst="rect">
-            <a:avLst/>
-          </a:prstGeom>
-          <a:noFill/>
-          <a:ln>
-            <a:noFill/>
-          </a:ln>
-        </p:spPr>
-        <p:txBody>
-          <a:bodyPr spcFirstLastPara="1" wrap="square" lIns="91425" tIns="45700" rIns="91425" bIns="45700" anchor="ctr" anchorCtr="0">
-            <a:noAutofit/>
-          </a:bodyPr>
-          <a:lstStyle>
-            <a:lvl1pPr lvl="0" algn="ctr">
-              <a:spcBef>
-                <a:spcPts val="0"/>
-              </a:spcBef>
-              <a:spcAft>
-                <a:spcPts val="0"/>
-              </a:spcAft>
-              <a:buSzPts val="1400"/>
-              <a:buNone/>
-              <a:defRPr/>
-            </a:lvl1pPr>
-            <a:lvl2pPr lvl="1" algn="l">
-              <a:spcBef>
-                <a:spcPts val="0"/>
-              </a:spcBef>
-              <a:spcAft>
-                <a:spcPts val="0"/>
-              </a:spcAft>
-              <a:buSzPts val="1400"/>
-              <a:buNone/>
-              <a:defRPr/>
-            </a:lvl2pPr>
-            <a:lvl3pPr lvl="2" algn="l">
-              <a:spcBef>
-                <a:spcPts val="0"/>
-              </a:spcBef>
-              <a:spcAft>
-                <a:spcPts val="0"/>
-              </a:spcAft>
-              <a:buSzPts val="1400"/>
-              <a:buNone/>
-              <a:defRPr/>
-            </a:lvl3pPr>
-            <a:lvl4pPr lvl="3" algn="l">
-              <a:spcBef>
-                <a:spcPts val="0"/>
-              </a:spcBef>
-              <a:spcAft>
-                <a:spcPts val="0"/>
-              </a:spcAft>
-              <a:buSzPts val="1400"/>
-              <a:buNone/>
-              <a:defRPr/>
-            </a:lvl4pPr>
-            <a:lvl5pPr lvl="4" algn="l">
-              <a:spcBef>
-                <a:spcPts val="0"/>
-              </a:spcBef>
-              <a:spcAft>
-                <a:spcPts val="0"/>
-              </a:spcAft>
-              <a:buSzPts val="1400"/>
-              <a:buNone/>
-              <a:defRPr/>
-            </a:lvl5pPr>
-            <a:lvl6pPr lvl="5" algn="l">
-              <a:spcBef>
-                <a:spcPts val="0"/>
-              </a:spcBef>
-              <a:spcAft>
-                <a:spcPts val="0"/>
-              </a:spcAft>
-              <a:buSzPts val="1400"/>
-              <a:buNone/>
-              <a:defRPr/>
-            </a:lvl6pPr>
-            <a:lvl7pPr lvl="6" algn="l">
-              <a:spcBef>
-                <a:spcPts val="0"/>
-              </a:spcBef>
-              <a:spcAft>
-                <a:spcPts val="0"/>
-              </a:spcAft>
-              <a:buSzPts val="1400"/>
-              <a:buNone/>
-              <a:defRPr/>
-            </a:lvl7pPr>
-            <a:lvl8pPr lvl="7" algn="l">
-              <a:spcBef>
-                <a:spcPts val="0"/>
-              </a:spcBef>
-              <a:spcAft>
-                <a:spcPts val="0"/>
-              </a:spcAft>
-              <a:buSzPts val="1400"/>
-              <a:buNone/>
-              <a:defRPr/>
-            </a:lvl8pPr>
-            <a:lvl9pPr lvl="8" algn="l">
-              <a:spcBef>
-                <a:spcPts val="0"/>
-              </a:spcBef>
-              <a:spcAft>
-                <a:spcPts val="0"/>
-              </a:spcAft>
-              <a:buSzPts val="1400"/>
-              <a:buNone/>
-              <a:defRPr/>
-            </a:lvl9pPr>
-          </a:lstStyle>
-          <a:p>
-            <a:pPr marL="0" marR="0" lvl="0" indent="0" algn="ctr" defTabSz="914400" rtl="0" eaLnBrk="1" fontAlgn="auto" latinLnBrk="0" hangingPunct="1">
-              <a:lnSpc>
-                <a:spcPct val="100000"/>
-              </a:lnSpc>
-              <a:spcBef>
-                <a:spcPts val="0"/>
-              </a:spcBef>
-              <a:spcAft>
-                <a:spcPts val="0"/>
-              </a:spcAft>
-              <a:buClr>
-                <a:srgbClr val="000000"/>
-              </a:buClr>
-              <a:buSzPts val="1400"/>
-              <a:buFont typeface="Arial"/>
-              <a:buNone/>
-              <a:tabLst/>
-              <a:defRPr/>
-            </a:pPr>
-            <a:r>
-              <a:rPr kumimoji="0" lang="en-US" sz="1200" b="0" i="0" u="none" strike="noStrike" kern="0" cap="none" spc="0" normalizeH="0" baseline="0" noProof="0" dirty="0">
-                <a:ln>
-                  <a:noFill/>
-                </a:ln>
-                <a:solidFill>
-                  <a:srgbClr val="888888"/>
-                </a:solidFill>
-                <a:effectLst/>
-                <a:uLnTx/>
-                <a:uFillTx/>
-                <a:latin typeface="Calibri"/>
-                <a:cs typeface="Calibri"/>
-                <a:sym typeface="Calibri"/>
-              </a:rPr>
-              <a:t>Proprietary and Confidential Information</a:t>
-            </a:r>
-            <a:endParaRPr kumimoji="0" sz="1200" b="0" i="0" u="none" strike="noStrike" kern="0" cap="none" spc="0" normalizeH="0" baseline="0" noProof="0" dirty="0">
-              <a:ln>
-                <a:noFill/>
-              </a:ln>
-              <a:solidFill>
-                <a:srgbClr val="888888"/>
-              </a:solidFill>
-              <a:effectLst/>
-              <a:uLnTx/>
-              <a:uFillTx/>
-              <a:latin typeface="Calibri"/>
-              <a:cs typeface="Calibri"/>
-              <a:sym typeface="Calibri"/>
-            </a:endParaRPr>
-          </a:p>
-        </p:txBody>
-      </p:sp>
     </p:spTree>
     <p:extLst>
       <p:ext uri="{BB962C8B-B14F-4D97-AF65-F5344CB8AC3E}">
@@ -18852,194 +17687,6 @@
           </a:graphicData>
         </a:graphic>
       </p:graphicFrame>
-      <p:sp>
-        <p:nvSpPr>
-          <p:cNvPr id="2" name="Google Shape;18;p9">
-            <a:extLst>
-              <a:ext uri="{FF2B5EF4-FFF2-40B4-BE49-F238E27FC236}">
-                <a16:creationId xmlns:a16="http://schemas.microsoft.com/office/drawing/2014/main" id="{A837E304-B0E0-78B0-2263-1A31EE4658E7}"/>
-              </a:ext>
-            </a:extLst>
-          </p:cNvPr>
-          <p:cNvSpPr txBox="1">
-            <a:spLocks noGrp="1"/>
-          </p:cNvSpPr>
-          <p:nvPr>
-            <p:ph type="ftr" idx="11"/>
-          </p:nvPr>
-        </p:nvSpPr>
-        <p:spPr>
-          <a:xfrm>
-            <a:off x="4038600" y="6356350"/>
-            <a:ext cx="4114800" cy="365125"/>
-          </a:xfrm>
-          <a:prstGeom prst="rect">
-            <a:avLst/>
-          </a:prstGeom>
-          <a:noFill/>
-          <a:ln>
-            <a:noFill/>
-          </a:ln>
-        </p:spPr>
-        <p:txBody>
-          <a:bodyPr spcFirstLastPara="1" wrap="square" lIns="91425" tIns="45700" rIns="91425" bIns="45700" anchor="ctr" anchorCtr="0">
-            <a:noAutofit/>
-          </a:bodyPr>
-          <a:lstStyle>
-            <a:lvl1pPr lvl="0" algn="ctr">
-              <a:spcBef>
-                <a:spcPts val="0"/>
-              </a:spcBef>
-              <a:spcAft>
-                <a:spcPts val="0"/>
-              </a:spcAft>
-              <a:buSzPts val="1400"/>
-              <a:buNone/>
-              <a:defRPr/>
-            </a:lvl1pPr>
-            <a:lvl2pPr lvl="1" algn="l">
-              <a:spcBef>
-                <a:spcPts val="0"/>
-              </a:spcBef>
-              <a:spcAft>
-                <a:spcPts val="0"/>
-              </a:spcAft>
-              <a:buSzPts val="1400"/>
-              <a:buNone/>
-              <a:defRPr/>
-            </a:lvl2pPr>
-            <a:lvl3pPr lvl="2" algn="l">
-              <a:spcBef>
-                <a:spcPts val="0"/>
-              </a:spcBef>
-              <a:spcAft>
-                <a:spcPts val="0"/>
-              </a:spcAft>
-              <a:buSzPts val="1400"/>
-              <a:buNone/>
-              <a:defRPr/>
-            </a:lvl3pPr>
-            <a:lvl4pPr lvl="3" algn="l">
-              <a:spcBef>
-                <a:spcPts val="0"/>
-              </a:spcBef>
-              <a:spcAft>
-                <a:spcPts val="0"/>
-              </a:spcAft>
-              <a:buSzPts val="1400"/>
-              <a:buNone/>
-              <a:defRPr/>
-            </a:lvl4pPr>
-            <a:lvl5pPr lvl="4" algn="l">
-              <a:spcBef>
-                <a:spcPts val="0"/>
-              </a:spcBef>
-              <a:spcAft>
-                <a:spcPts val="0"/>
-              </a:spcAft>
-              <a:buSzPts val="1400"/>
-              <a:buNone/>
-              <a:defRPr/>
-            </a:lvl5pPr>
-            <a:lvl6pPr lvl="5" algn="l">
-              <a:spcBef>
-                <a:spcPts val="0"/>
-              </a:spcBef>
-              <a:spcAft>
-                <a:spcPts val="0"/>
-              </a:spcAft>
-              <a:buSzPts val="1400"/>
-              <a:buNone/>
-              <a:defRPr/>
-            </a:lvl6pPr>
-            <a:lvl7pPr lvl="6" algn="l">
-              <a:spcBef>
-                <a:spcPts val="0"/>
-              </a:spcBef>
-              <a:spcAft>
-                <a:spcPts val="0"/>
-              </a:spcAft>
-              <a:buSzPts val="1400"/>
-              <a:buNone/>
-              <a:defRPr/>
-            </a:lvl7pPr>
-            <a:lvl8pPr lvl="7" algn="l">
-              <a:spcBef>
-                <a:spcPts val="0"/>
-              </a:spcBef>
-              <a:spcAft>
-                <a:spcPts val="0"/>
-              </a:spcAft>
-              <a:buSzPts val="1400"/>
-              <a:buNone/>
-              <a:defRPr/>
-            </a:lvl8pPr>
-            <a:lvl9pPr lvl="8" algn="l">
-              <a:spcBef>
-                <a:spcPts val="0"/>
-              </a:spcBef>
-              <a:spcAft>
-                <a:spcPts val="0"/>
-              </a:spcAft>
-              <a:buSzPts val="1400"/>
-              <a:buNone/>
-              <a:defRPr/>
-            </a:lvl9pPr>
-          </a:lstStyle>
-          <a:p>
-            <a:pPr marL="0" marR="0" lvl="0" indent="0" algn="ctr" defTabSz="914400" rtl="0" eaLnBrk="1" fontAlgn="auto" latinLnBrk="0" hangingPunct="1">
-              <a:lnSpc>
-                <a:spcPct val="100000"/>
-              </a:lnSpc>
-              <a:spcBef>
-                <a:spcPts val="0"/>
-              </a:spcBef>
-              <a:spcAft>
-                <a:spcPts val="0"/>
-              </a:spcAft>
-              <a:buClr>
-                <a:srgbClr val="000000"/>
-              </a:buClr>
-              <a:buSzPts val="1400"/>
-              <a:buFont typeface="Arial"/>
-              <a:buNone/>
-              <a:tabLst/>
-              <a:defRPr/>
-            </a:pPr>
-            <a:r>
-              <a:rPr kumimoji="0" lang="en-US" sz="1200" b="0" i="0" u="none" strike="noStrike" kern="0" cap="none" spc="0" normalizeH="0" baseline="0" noProof="0" dirty="0">
-                <a:ln>
-                  <a:noFill/>
-                </a:ln>
-                <a:solidFill>
-                  <a:srgbClr val="888888"/>
-                </a:solidFill>
-                <a:effectLst/>
-                <a:uLnTx/>
-                <a:uFillTx/>
-                <a:latin typeface="Calibri"/>
-                <a:cs typeface="Calibri"/>
-                <a:sym typeface="Calibri"/>
-              </a:rPr>
-              <a:t>Proprietary and Confidential Information</a:t>
-            </a:r>
-            <a:endParaRPr kumimoji="0" sz="1200" b="0" i="0" u="none" strike="noStrike" kern="0" cap="none" spc="0" normalizeH="0" baseline="0" noProof="0" dirty="0">
-              <a:ln>
-                <a:noFill/>
-              </a:ln>
-              <a:solidFill>
-                <a:srgbClr val="888888"/>
-              </a:solidFill>
-              <a:effectLst/>
-              <a:uLnTx/>
-              <a:uFillTx/>
-              <a:latin typeface="Calibri"/>
-              <a:cs typeface="Calibri"/>
-              <a:sym typeface="Calibri"/>
-            </a:endParaRPr>
-          </a:p>
-        </p:txBody>
-      </p:sp>
     </p:spTree>
     <p:extLst>
       <p:ext uri="{BB962C8B-B14F-4D97-AF65-F5344CB8AC3E}">
@@ -19918,194 +18565,6 @@
           </a:graphicData>
         </a:graphic>
       </p:graphicFrame>
-      <p:sp>
-        <p:nvSpPr>
-          <p:cNvPr id="2" name="Google Shape;18;p9">
-            <a:extLst>
-              <a:ext uri="{FF2B5EF4-FFF2-40B4-BE49-F238E27FC236}">
-                <a16:creationId xmlns:a16="http://schemas.microsoft.com/office/drawing/2014/main" id="{7FEDDB3B-2B33-FC16-9957-17D50DC8B784}"/>
-              </a:ext>
-            </a:extLst>
-          </p:cNvPr>
-          <p:cNvSpPr txBox="1">
-            <a:spLocks noGrp="1"/>
-          </p:cNvSpPr>
-          <p:nvPr>
-            <p:ph type="ftr" idx="11"/>
-          </p:nvPr>
-        </p:nvSpPr>
-        <p:spPr>
-          <a:xfrm>
-            <a:off x="4038600" y="6356350"/>
-            <a:ext cx="4114800" cy="365125"/>
-          </a:xfrm>
-          <a:prstGeom prst="rect">
-            <a:avLst/>
-          </a:prstGeom>
-          <a:noFill/>
-          <a:ln>
-            <a:noFill/>
-          </a:ln>
-        </p:spPr>
-        <p:txBody>
-          <a:bodyPr spcFirstLastPara="1" wrap="square" lIns="91425" tIns="45700" rIns="91425" bIns="45700" anchor="ctr" anchorCtr="0">
-            <a:noAutofit/>
-          </a:bodyPr>
-          <a:lstStyle>
-            <a:lvl1pPr lvl="0" algn="ctr">
-              <a:spcBef>
-                <a:spcPts val="0"/>
-              </a:spcBef>
-              <a:spcAft>
-                <a:spcPts val="0"/>
-              </a:spcAft>
-              <a:buSzPts val="1400"/>
-              <a:buNone/>
-              <a:defRPr/>
-            </a:lvl1pPr>
-            <a:lvl2pPr lvl="1" algn="l">
-              <a:spcBef>
-                <a:spcPts val="0"/>
-              </a:spcBef>
-              <a:spcAft>
-                <a:spcPts val="0"/>
-              </a:spcAft>
-              <a:buSzPts val="1400"/>
-              <a:buNone/>
-              <a:defRPr/>
-            </a:lvl2pPr>
-            <a:lvl3pPr lvl="2" algn="l">
-              <a:spcBef>
-                <a:spcPts val="0"/>
-              </a:spcBef>
-              <a:spcAft>
-                <a:spcPts val="0"/>
-              </a:spcAft>
-              <a:buSzPts val="1400"/>
-              <a:buNone/>
-              <a:defRPr/>
-            </a:lvl3pPr>
-            <a:lvl4pPr lvl="3" algn="l">
-              <a:spcBef>
-                <a:spcPts val="0"/>
-              </a:spcBef>
-              <a:spcAft>
-                <a:spcPts val="0"/>
-              </a:spcAft>
-              <a:buSzPts val="1400"/>
-              <a:buNone/>
-              <a:defRPr/>
-            </a:lvl4pPr>
-            <a:lvl5pPr lvl="4" algn="l">
-              <a:spcBef>
-                <a:spcPts val="0"/>
-              </a:spcBef>
-              <a:spcAft>
-                <a:spcPts val="0"/>
-              </a:spcAft>
-              <a:buSzPts val="1400"/>
-              <a:buNone/>
-              <a:defRPr/>
-            </a:lvl5pPr>
-            <a:lvl6pPr lvl="5" algn="l">
-              <a:spcBef>
-                <a:spcPts val="0"/>
-              </a:spcBef>
-              <a:spcAft>
-                <a:spcPts val="0"/>
-              </a:spcAft>
-              <a:buSzPts val="1400"/>
-              <a:buNone/>
-              <a:defRPr/>
-            </a:lvl6pPr>
-            <a:lvl7pPr lvl="6" algn="l">
-              <a:spcBef>
-                <a:spcPts val="0"/>
-              </a:spcBef>
-              <a:spcAft>
-                <a:spcPts val="0"/>
-              </a:spcAft>
-              <a:buSzPts val="1400"/>
-              <a:buNone/>
-              <a:defRPr/>
-            </a:lvl7pPr>
-            <a:lvl8pPr lvl="7" algn="l">
-              <a:spcBef>
-                <a:spcPts val="0"/>
-              </a:spcBef>
-              <a:spcAft>
-                <a:spcPts val="0"/>
-              </a:spcAft>
-              <a:buSzPts val="1400"/>
-              <a:buNone/>
-              <a:defRPr/>
-            </a:lvl8pPr>
-            <a:lvl9pPr lvl="8" algn="l">
-              <a:spcBef>
-                <a:spcPts val="0"/>
-              </a:spcBef>
-              <a:spcAft>
-                <a:spcPts val="0"/>
-              </a:spcAft>
-              <a:buSzPts val="1400"/>
-              <a:buNone/>
-              <a:defRPr/>
-            </a:lvl9pPr>
-          </a:lstStyle>
-          <a:p>
-            <a:pPr marL="0" marR="0" lvl="0" indent="0" algn="ctr" defTabSz="914400" rtl="0" eaLnBrk="1" fontAlgn="auto" latinLnBrk="0" hangingPunct="1">
-              <a:lnSpc>
-                <a:spcPct val="100000"/>
-              </a:lnSpc>
-              <a:spcBef>
-                <a:spcPts val="0"/>
-              </a:spcBef>
-              <a:spcAft>
-                <a:spcPts val="0"/>
-              </a:spcAft>
-              <a:buClr>
-                <a:srgbClr val="000000"/>
-              </a:buClr>
-              <a:buSzPts val="1400"/>
-              <a:buFont typeface="Arial"/>
-              <a:buNone/>
-              <a:tabLst/>
-              <a:defRPr/>
-            </a:pPr>
-            <a:r>
-              <a:rPr kumimoji="0" lang="en-US" sz="1200" b="0" i="0" u="none" strike="noStrike" kern="0" cap="none" spc="0" normalizeH="0" baseline="0" noProof="0" dirty="0">
-                <a:ln>
-                  <a:noFill/>
-                </a:ln>
-                <a:solidFill>
-                  <a:srgbClr val="888888"/>
-                </a:solidFill>
-                <a:effectLst/>
-                <a:uLnTx/>
-                <a:uFillTx/>
-                <a:latin typeface="Calibri"/>
-                <a:cs typeface="Calibri"/>
-                <a:sym typeface="Calibri"/>
-              </a:rPr>
-              <a:t>Proprietary and Confidential Information</a:t>
-            </a:r>
-            <a:endParaRPr kumimoji="0" sz="1200" b="0" i="0" u="none" strike="noStrike" kern="0" cap="none" spc="0" normalizeH="0" baseline="0" noProof="0" dirty="0">
-              <a:ln>
-                <a:noFill/>
-              </a:ln>
-              <a:solidFill>
-                <a:srgbClr val="888888"/>
-              </a:solidFill>
-              <a:effectLst/>
-              <a:uLnTx/>
-              <a:uFillTx/>
-              <a:latin typeface="Calibri"/>
-              <a:cs typeface="Calibri"/>
-              <a:sym typeface="Calibri"/>
-            </a:endParaRPr>
-          </a:p>
-        </p:txBody>
-      </p:sp>
     </p:spTree>
     <p:extLst>
       <p:ext uri="{BB962C8B-B14F-4D97-AF65-F5344CB8AC3E}">

</xml_diff>

<commit_message>
Updated 3Horizon Strategy Graphic
</commit_message>
<xml_diff>
--- a/docs/1_Integration/1a_Governance/AccelRR8 Consortium Non-Profit Organization Plan.pptx
+++ b/docs/1_Integration/1a_Governance/AccelRR8 Consortium Non-Profit Organization Plan.pptx
@@ -253,18 +253,10 @@
       <p15:sldGuideLst xmlns:p15="http://schemas.microsoft.com/office/powerpoint/2012/main"/>
     </p:ext>
     <p:ext uri="GoogleSlidesCustomDataVersion2">
-      <go:slidesCustomData xmlns:go="http://customooxmlschemas.google.com/" xmlns:ahyp="http://schemas.microsoft.com/office/drawing/2018/hyperlinkcolor" xmlns:p15="http://schemas.microsoft.com/office/powerpoint/2012/main" xmlns:p14="http://schemas.microsoft.com/office/powerpoint/2010/main" xmlns:com="http://schemas.openxmlformats.org/drawingml/2006/compatibility" xmlns:pvml="urn:schemas-microsoft-com:office:powerpoint" xmlns:v="urn:schemas-microsoft-com:vml" xmlns:o="urn:schemas-microsoft-com:office:office" xmlns:dgm="http://schemas.openxmlformats.org/drawingml/2006/diagram" xmlns:c="http://schemas.openxmlformats.org/drawingml/2006/chart" xmlns:mv="urn:schemas-microsoft-com:mac:vml" xmlns:mc="http://schemas.openxmlformats.org/markup-compatibility/2006" xmlns="" r:id="rId13" roundtripDataSignature="AMtx7mhwEp+Eio5qReXqYqUwMP31HB0A8A=="/>
+      <go:slidesCustomData xmlns="" xmlns:mc="http://schemas.openxmlformats.org/markup-compatibility/2006" xmlns:mv="urn:schemas-microsoft-com:mac:vml" xmlns:c="http://schemas.openxmlformats.org/drawingml/2006/chart" xmlns:dgm="http://schemas.openxmlformats.org/drawingml/2006/diagram" xmlns:o="urn:schemas-microsoft-com:office:office" xmlns:v="urn:schemas-microsoft-com:vml" xmlns:pvml="urn:schemas-microsoft-com:office:powerpoint" xmlns:com="http://schemas.openxmlformats.org/drawingml/2006/compatibility" xmlns:p14="http://schemas.microsoft.com/office/powerpoint/2010/main" xmlns:p15="http://schemas.microsoft.com/office/powerpoint/2012/main" xmlns:ahyp="http://schemas.microsoft.com/office/drawing/2018/hyperlinkcolor" xmlns:go="http://customooxmlschemas.google.com/" r:id="rId13" roundtripDataSignature="AMtx7mhwEp+Eio5qReXqYqUwMP31HB0A8A=="/>
     </p:ext>
   </p:extLst>
 </p:presentation>
-</file>
-
-<file path=ppt/revisionInfo.xml><?xml version="1.0" encoding="utf-8"?>
-<p1510:revInfo xmlns:a="http://schemas.openxmlformats.org/drawingml/2006/main" xmlns:r="http://schemas.openxmlformats.org/officeDocument/2006/relationships" xmlns:p1510="http://schemas.microsoft.com/office/powerpoint/2015/10/main">
-  <p1510:revLst>
-    <p1510:client id="{A9042BD1-3682-2948-BF46-D110B0AEEC3F}" v="3" dt="2026-08-06T16:33:07.209"/>
-  </p1510:revLst>
-</p1510:revInfo>
 </file>
 
 <file path=ppt/changesInfos/changesInfo1.xml><?xml version="1.0" encoding="utf-8"?>
@@ -272,7 +264,7 @@
   <pc:docChgLst>
     <pc:chgData name="Rich Reba" userId="55db41ab6eb3f845" providerId="LiveId" clId="{0E19DA16-244C-5B50-BE0F-52911DD4CA7E}"/>
     <pc:docChg chg="undo custSel modSld">
-      <pc:chgData name="Rich Reba" userId="55db41ab6eb3f845" providerId="LiveId" clId="{0E19DA16-244C-5B50-BE0F-52911DD4CA7E}" dt="2026-08-10T12:07:20.066" v="527" actId="478"/>
+      <pc:chgData name="Rich Reba" userId="55db41ab6eb3f845" providerId="LiveId" clId="{0E19DA16-244C-5B50-BE0F-52911DD4CA7E}" dt="2026-09-08T14:27:15.031" v="542" actId="20577"/>
       <pc:docMkLst>
         <pc:docMk/>
       </pc:docMkLst>
@@ -282,22 +274,6 @@
           <pc:docMk/>
           <pc:sldMk cId="0" sldId="256"/>
         </pc:sldMkLst>
-        <pc:spChg chg="del">
-          <ac:chgData name="Rich Reba" userId="55db41ab6eb3f845" providerId="LiveId" clId="{0E19DA16-244C-5B50-BE0F-52911DD4CA7E}" dt="2026-08-10T12:06:55.065" v="522" actId="478"/>
-          <ac:spMkLst>
-            <pc:docMk/>
-            <pc:sldMk cId="0" sldId="256"/>
-            <ac:spMk id="2" creationId="{00C41C28-1F72-7447-74D3-F57B36646C52}"/>
-          </ac:spMkLst>
-        </pc:spChg>
-        <pc:spChg chg="mod">
-          <ac:chgData name="Rich Reba" userId="55db41ab6eb3f845" providerId="LiveId" clId="{0E19DA16-244C-5B50-BE0F-52911DD4CA7E}" dt="2026-08-06T16:20:55.520" v="9" actId="20577"/>
-          <ac:spMkLst>
-            <pc:docMk/>
-            <pc:sldMk cId="0" sldId="256"/>
-            <ac:spMk id="91" creationId="{00000000-0000-0000-0000-000000000000}"/>
-          </ac:spMkLst>
-        </pc:spChg>
       </pc:sldChg>
       <pc:sldChg chg="delSp mod">
         <pc:chgData name="Rich Reba" userId="55db41ab6eb3f845" providerId="LiveId" clId="{0E19DA16-244C-5B50-BE0F-52911DD4CA7E}" dt="2026-08-10T12:06:52.373" v="521" actId="478"/>
@@ -305,31 +281,15 @@
           <pc:docMk/>
           <pc:sldMk cId="0" sldId="257"/>
         </pc:sldMkLst>
-        <pc:spChg chg="del">
-          <ac:chgData name="Rich Reba" userId="55db41ab6eb3f845" providerId="LiveId" clId="{0E19DA16-244C-5B50-BE0F-52911DD4CA7E}" dt="2026-08-10T12:06:52.373" v="521" actId="478"/>
-          <ac:spMkLst>
-            <pc:docMk/>
-            <pc:sldMk cId="0" sldId="257"/>
-            <ac:spMk id="2" creationId="{2F16A1F0-E195-BF45-032B-42BF906BEC9A}"/>
-          </ac:spMkLst>
-        </pc:spChg>
       </pc:sldChg>
       <pc:sldChg chg="delSp modSp mod">
-        <pc:chgData name="Rich Reba" userId="55db41ab6eb3f845" providerId="LiveId" clId="{0E19DA16-244C-5B50-BE0F-52911DD4CA7E}" dt="2026-08-10T12:06:59.856" v="523" actId="478"/>
+        <pc:chgData name="Rich Reba" userId="55db41ab6eb3f845" providerId="LiveId" clId="{0E19DA16-244C-5B50-BE0F-52911DD4CA7E}" dt="2026-09-08T14:27:15.031" v="542" actId="20577"/>
         <pc:sldMkLst>
           <pc:docMk/>
           <pc:sldMk cId="1656586467" sldId="274"/>
         </pc:sldMkLst>
-        <pc:spChg chg="del">
-          <ac:chgData name="Rich Reba" userId="55db41ab6eb3f845" providerId="LiveId" clId="{0E19DA16-244C-5B50-BE0F-52911DD4CA7E}" dt="2026-08-10T12:06:59.856" v="523" actId="478"/>
-          <ac:spMkLst>
-            <pc:docMk/>
-            <pc:sldMk cId="1656586467" sldId="274"/>
-            <ac:spMk id="6" creationId="{CF348359-6A33-94C2-7023-E826A712A5B3}"/>
-          </ac:spMkLst>
-        </pc:spChg>
         <pc:spChg chg="mod">
-          <ac:chgData name="Rich Reba" userId="55db41ab6eb3f845" providerId="LiveId" clId="{0E19DA16-244C-5B50-BE0F-52911DD4CA7E}" dt="2026-08-06T16:21:32.989" v="10" actId="20577"/>
+          <ac:chgData name="Rich Reba" userId="55db41ab6eb3f845" providerId="LiveId" clId="{0E19DA16-244C-5B50-BE0F-52911DD4CA7E}" dt="2026-09-08T14:27:04.873" v="533" actId="20577"/>
           <ac:spMkLst>
             <pc:docMk/>
             <pc:sldMk cId="1656586467" sldId="274"/>
@@ -337,7 +297,7 @@
           </ac:spMkLst>
         </pc:spChg>
         <pc:spChg chg="mod">
-          <ac:chgData name="Rich Reba" userId="55db41ab6eb3f845" providerId="LiveId" clId="{0E19DA16-244C-5B50-BE0F-52911DD4CA7E}" dt="2026-08-06T16:21:37.712" v="11" actId="20577"/>
+          <ac:chgData name="Rich Reba" userId="55db41ab6eb3f845" providerId="LiveId" clId="{0E19DA16-244C-5B50-BE0F-52911DD4CA7E}" dt="2026-09-08T14:27:09.388" v="538" actId="20577"/>
           <ac:spMkLst>
             <pc:docMk/>
             <pc:sldMk cId="1656586467" sldId="274"/>
@@ -345,35 +305,11 @@
           </ac:spMkLst>
         </pc:spChg>
         <pc:spChg chg="mod">
-          <ac:chgData name="Rich Reba" userId="55db41ab6eb3f845" providerId="LiveId" clId="{0E19DA16-244C-5B50-BE0F-52911DD4CA7E}" dt="2026-08-06T16:21:42.694" v="12" actId="20577"/>
+          <ac:chgData name="Rich Reba" userId="55db41ab6eb3f845" providerId="LiveId" clId="{0E19DA16-244C-5B50-BE0F-52911DD4CA7E}" dt="2026-09-08T14:27:15.031" v="542" actId="20577"/>
           <ac:spMkLst>
             <pc:docMk/>
             <pc:sldMk cId="1656586467" sldId="274"/>
             <ac:spMk id="127" creationId="{00000000-0000-0000-0000-000000000000}"/>
-          </ac:spMkLst>
-        </pc:spChg>
-        <pc:spChg chg="mod">
-          <ac:chgData name="Rich Reba" userId="55db41ab6eb3f845" providerId="LiveId" clId="{0E19DA16-244C-5B50-BE0F-52911DD4CA7E}" dt="2026-08-06T16:40:44.419" v="501" actId="20577"/>
-          <ac:spMkLst>
-            <pc:docMk/>
-            <pc:sldMk cId="1656586467" sldId="274"/>
-            <ac:spMk id="128" creationId="{00000000-0000-0000-0000-000000000000}"/>
-          </ac:spMkLst>
-        </pc:spChg>
-        <pc:spChg chg="mod">
-          <ac:chgData name="Rich Reba" userId="55db41ab6eb3f845" providerId="LiveId" clId="{0E19DA16-244C-5B50-BE0F-52911DD4CA7E}" dt="2026-08-06T16:40:47.360" v="503" actId="20577"/>
-          <ac:spMkLst>
-            <pc:docMk/>
-            <pc:sldMk cId="1656586467" sldId="274"/>
-            <ac:spMk id="129" creationId="{00000000-0000-0000-0000-000000000000}"/>
-          </ac:spMkLst>
-        </pc:spChg>
-        <pc:spChg chg="mod">
-          <ac:chgData name="Rich Reba" userId="55db41ab6eb3f845" providerId="LiveId" clId="{0E19DA16-244C-5B50-BE0F-52911DD4CA7E}" dt="2026-08-06T16:40:50.057" v="505" actId="20577"/>
-          <ac:spMkLst>
-            <pc:docMk/>
-            <pc:sldMk cId="1656586467" sldId="274"/>
-            <ac:spMk id="130" creationId="{00000000-0000-0000-0000-000000000000}"/>
           </ac:spMkLst>
         </pc:spChg>
       </pc:sldChg>
@@ -383,30 +319,6 @@
           <pc:docMk/>
           <pc:sldMk cId="3472351846" sldId="280"/>
         </pc:sldMkLst>
-        <pc:spChg chg="del">
-          <ac:chgData name="Rich Reba" userId="55db41ab6eb3f845" providerId="LiveId" clId="{0E19DA16-244C-5B50-BE0F-52911DD4CA7E}" dt="2026-08-10T12:06:48.887" v="520" actId="478"/>
-          <ac:spMkLst>
-            <pc:docMk/>
-            <pc:sldMk cId="3472351846" sldId="280"/>
-            <ac:spMk id="2" creationId="{4B602561-35D8-AF27-76E9-EB18F18FC081}"/>
-          </ac:spMkLst>
-        </pc:spChg>
-        <pc:spChg chg="mod">
-          <ac:chgData name="Rich Reba" userId="55db41ab6eb3f845" providerId="LiveId" clId="{0E19DA16-244C-5B50-BE0F-52911DD4CA7E}" dt="2026-08-06T16:41:04.023" v="517" actId="20577"/>
-          <ac:spMkLst>
-            <pc:docMk/>
-            <pc:sldMk cId="3472351846" sldId="280"/>
-            <ac:spMk id="4" creationId="{BDC3AF1A-7A80-3B3D-294A-E26C982690C3}"/>
-          </ac:spMkLst>
-        </pc:spChg>
-        <pc:spChg chg="mod">
-          <ac:chgData name="Rich Reba" userId="55db41ab6eb3f845" providerId="LiveId" clId="{0E19DA16-244C-5B50-BE0F-52911DD4CA7E}" dt="2026-08-06T16:41:43.287" v="519" actId="20577"/>
-          <ac:spMkLst>
-            <pc:docMk/>
-            <pc:sldMk cId="3472351846" sldId="280"/>
-            <ac:spMk id="5" creationId="{27DCB550-ECF5-EE2D-D835-8F66E64FAB2B}"/>
-          </ac:spMkLst>
-        </pc:spChg>
       </pc:sldChg>
       <pc:sldChg chg="delSp modSp mod">
         <pc:chgData name="Rich Reba" userId="55db41ab6eb3f845" providerId="LiveId" clId="{0E19DA16-244C-5B50-BE0F-52911DD4CA7E}" dt="2026-08-10T12:07:12.357" v="525" actId="478"/>
@@ -414,22 +326,6 @@
           <pc:docMk/>
           <pc:sldMk cId="4015092339" sldId="418"/>
         </pc:sldMkLst>
-        <pc:spChg chg="del">
-          <ac:chgData name="Rich Reba" userId="55db41ab6eb3f845" providerId="LiveId" clId="{0E19DA16-244C-5B50-BE0F-52911DD4CA7E}" dt="2026-08-10T12:07:12.357" v="525" actId="478"/>
-          <ac:spMkLst>
-            <pc:docMk/>
-            <pc:sldMk cId="4015092339" sldId="418"/>
-            <ac:spMk id="2" creationId="{462B9D62-4B92-3A8C-DA14-A225E2194D1F}"/>
-          </ac:spMkLst>
-        </pc:spChg>
-        <pc:graphicFrameChg chg="modGraphic">
-          <ac:chgData name="Rich Reba" userId="55db41ab6eb3f845" providerId="LiveId" clId="{0E19DA16-244C-5B50-BE0F-52911DD4CA7E}" dt="2026-08-06T16:28:21.663" v="199" actId="20577"/>
-          <ac:graphicFrameMkLst>
-            <pc:docMk/>
-            <pc:sldMk cId="4015092339" sldId="418"/>
-            <ac:graphicFrameMk id="5" creationId="{235B1283-057C-D1F9-667A-3EEBAC74BD47}"/>
-          </ac:graphicFrameMkLst>
-        </pc:graphicFrameChg>
       </pc:sldChg>
       <pc:sldChg chg="delSp modSp mod">
         <pc:chgData name="Rich Reba" userId="55db41ab6eb3f845" providerId="LiveId" clId="{0E19DA16-244C-5B50-BE0F-52911DD4CA7E}" dt="2026-08-10T12:07:16.759" v="526" actId="478"/>
@@ -437,22 +333,6 @@
           <pc:docMk/>
           <pc:sldMk cId="3381750306" sldId="419"/>
         </pc:sldMkLst>
-        <pc:spChg chg="del">
-          <ac:chgData name="Rich Reba" userId="55db41ab6eb3f845" providerId="LiveId" clId="{0E19DA16-244C-5B50-BE0F-52911DD4CA7E}" dt="2026-08-10T12:07:16.759" v="526" actId="478"/>
-          <ac:spMkLst>
-            <pc:docMk/>
-            <pc:sldMk cId="3381750306" sldId="419"/>
-            <ac:spMk id="2" creationId="{A837E304-B0E0-78B0-2263-1A31EE4658E7}"/>
-          </ac:spMkLst>
-        </pc:spChg>
-        <pc:graphicFrameChg chg="modGraphic">
-          <ac:chgData name="Rich Reba" userId="55db41ab6eb3f845" providerId="LiveId" clId="{0E19DA16-244C-5B50-BE0F-52911DD4CA7E}" dt="2026-08-06T16:29:27.860" v="215" actId="20577"/>
-          <ac:graphicFrameMkLst>
-            <pc:docMk/>
-            <pc:sldMk cId="3381750306" sldId="419"/>
-            <ac:graphicFrameMk id="5" creationId="{417F50A2-0C5F-7265-363E-DF79C62015E0}"/>
-          </ac:graphicFrameMkLst>
-        </pc:graphicFrameChg>
       </pc:sldChg>
       <pc:sldChg chg="delSp modSp mod">
         <pc:chgData name="Rich Reba" userId="55db41ab6eb3f845" providerId="LiveId" clId="{0E19DA16-244C-5B50-BE0F-52911DD4CA7E}" dt="2026-08-10T12:07:20.066" v="527" actId="478"/>
@@ -460,22 +340,6 @@
           <pc:docMk/>
           <pc:sldMk cId="4209041106" sldId="420"/>
         </pc:sldMkLst>
-        <pc:spChg chg="del">
-          <ac:chgData name="Rich Reba" userId="55db41ab6eb3f845" providerId="LiveId" clId="{0E19DA16-244C-5B50-BE0F-52911DD4CA7E}" dt="2026-08-10T12:07:20.066" v="527" actId="478"/>
-          <ac:spMkLst>
-            <pc:docMk/>
-            <pc:sldMk cId="4209041106" sldId="420"/>
-            <ac:spMk id="2" creationId="{7FEDDB3B-2B33-FC16-9957-17D50DC8B784}"/>
-          </ac:spMkLst>
-        </pc:spChg>
-        <pc:graphicFrameChg chg="mod modGraphic">
-          <ac:chgData name="Rich Reba" userId="55db41ab6eb3f845" providerId="LiveId" clId="{0E19DA16-244C-5B50-BE0F-52911DD4CA7E}" dt="2026-08-06T16:31:55.906" v="324" actId="20577"/>
-          <ac:graphicFrameMkLst>
-            <pc:docMk/>
-            <pc:sldMk cId="4209041106" sldId="420"/>
-            <ac:graphicFrameMk id="5" creationId="{4AC1DA23-72BB-F2F4-A1A5-6F5D3E4CFD56}"/>
-          </ac:graphicFrameMkLst>
-        </pc:graphicFrameChg>
       </pc:sldChg>
       <pc:sldChg chg="delSp modSp mod">
         <pc:chgData name="Rich Reba" userId="55db41ab6eb3f845" providerId="LiveId" clId="{0E19DA16-244C-5B50-BE0F-52911DD4CA7E}" dt="2026-08-10T12:07:07.331" v="524" actId="478"/>
@@ -483,22 +347,6 @@
           <pc:docMk/>
           <pc:sldMk cId="3765181648" sldId="421"/>
         </pc:sldMkLst>
-        <pc:spChg chg="del">
-          <ac:chgData name="Rich Reba" userId="55db41ab6eb3f845" providerId="LiveId" clId="{0E19DA16-244C-5B50-BE0F-52911DD4CA7E}" dt="2026-08-10T12:07:07.331" v="524" actId="478"/>
-          <ac:spMkLst>
-            <pc:docMk/>
-            <pc:sldMk cId="3765181648" sldId="421"/>
-            <ac:spMk id="2" creationId="{581D35DC-2D2E-4B81-D251-A66615F9BC3C}"/>
-          </ac:spMkLst>
-        </pc:spChg>
-        <pc:graphicFrameChg chg="mod modGraphic">
-          <ac:chgData name="Rich Reba" userId="55db41ab6eb3f845" providerId="LiveId" clId="{0E19DA16-244C-5B50-BE0F-52911DD4CA7E}" dt="2026-08-06T16:33:58.650" v="466" actId="20577"/>
-          <ac:graphicFrameMkLst>
-            <pc:docMk/>
-            <pc:sldMk cId="3765181648" sldId="421"/>
-            <ac:graphicFrameMk id="5" creationId="{2DF256E9-2562-2DB8-B11B-ABE07084E41A}"/>
-          </ac:graphicFrameMkLst>
-        </pc:graphicFrameChg>
       </pc:sldChg>
     </pc:docChg>
   </pc:docChgLst>
@@ -12764,7 +12612,7 @@
                 <a:cs typeface="Calibri"/>
                 <a:sym typeface="Calibri"/>
               </a:rPr>
-              <a:t>Pack a Snowball</a:t>
+              <a:t>Launch</a:t>
             </a:r>
             <a:br>
               <a:rPr lang="en-US" sz="2400" b="0" i="0" u="none" strike="noStrike" cap="none" dirty="0">
@@ -12837,7 +12685,7 @@
                 <a:cs typeface="Calibri"/>
                 <a:sym typeface="Calibri"/>
               </a:rPr>
-              <a:t>Roll it Downhill</a:t>
+              <a:t>Climb</a:t>
             </a:r>
             <a:br>
               <a:rPr lang="en-US" sz="2400" b="0" i="0" u="none" strike="noStrike" cap="none" dirty="0">
@@ -12901,7 +12749,7 @@
               <a:buNone/>
             </a:pPr>
             <a:r>
-              <a:rPr lang="en-US" sz="2400" b="0" i="0" u="none" strike="noStrike" cap="none" dirty="0">
+              <a:rPr lang="en-US" sz="2400" b="0" i="0" u="none" strike="noStrike" cap="none">
                 <a:solidFill>
                   <a:schemeClr val="lt1"/>
                 </a:solidFill>
@@ -12910,8 +12758,17 @@
                 <a:cs typeface="Calibri"/>
                 <a:sym typeface="Calibri"/>
               </a:rPr>
-              <a:t>Trigger an Avalanche</a:t>
+              <a:t>Soar</a:t>
             </a:r>
+            <a:endParaRPr lang="en-US" sz="2400" b="0" i="0" u="none" strike="noStrike" cap="none" dirty="0">
+              <a:solidFill>
+                <a:schemeClr val="lt1"/>
+              </a:solidFill>
+              <a:latin typeface="Calibri"/>
+              <a:ea typeface="Calibri"/>
+              <a:cs typeface="Calibri"/>
+              <a:sym typeface="Calibri"/>
+            </a:endParaRPr>
           </a:p>
           <a:p>
             <a:pPr marL="0" marR="0" lvl="0" indent="0" algn="ctr" rtl="0">

</xml_diff>